<commit_message>
Add unambiguous feature list (Live vs Planned) to deck, PPTX, and source
New "Exactly What We're Building" slide in /deck and the PPTX: a status-marked
feature matrix (9 LIVE modules + an explicit Planned/Phase 2-3 strip) so the
incubator sees precisely what exists vs what's roadmap. Deck slide engine now
auto-numbers by DOM order (insert-safe). Same list added to the LLM deck source.

Co-Authored-By: Claude Opus 4.8 <noreply@anthropic.com>
Claude-Session: https://claude.ai/code/session_01XWjJ1MEvrkkC4HSy2tmiRF
</commit_message>
<xml_diff>
--- a/presentation/Elevate-Homes-End-to-End-Deck.pptx
+++ b/presentation/Elevate-Homes-End-to-End-Deck.pptx
@@ -22,6 +22,7 @@
     <p:sldId id="270" r:id="rId22"/>
     <p:sldId id="271" r:id="rId23"/>
     <p:sldId id="272" r:id="rId24"/>
+    <p:sldId id="273" r:id="rId25"/>
   </p:sldIdLst>
   <p:sldSz cx="12191695" cy="6858000" type="screen4x3"/>
   <p:notesSz cx="6858000" cy="9144000"/>
@@ -588,7 +589,7 @@
           <a:lstStyle/>
           <a:p>
             <a:r>
-              <a:t>This is why it's PropTech, not 'another brokerage' — the asset compounds.</a:t>
+              <a:t>Forward projections; multiples illustrative, not a quote.</a:t>
             </a:r>
           </a:p>
         </p:txBody>
@@ -658,7 +659,7 @@
           <a:lstStyle/>
           <a:p>
             <a:r>
-              <a:t>Each stage is gated by proof from the previous one — capital follows traction.</a:t>
+              <a:t>This is why it's PropTech, not 'another brokerage' — the asset compounds.</a:t>
             </a:r>
           </a:p>
         </p:txBody>
@@ -728,7 +729,7 @@
           <a:lstStyle/>
           <a:p>
             <a:r>
-              <a:t>Show traction now; scale only on proof.</a:t>
+              <a:t>Each stage is gated by proof from the previous one — capital follows traction.</a:t>
             </a:r>
           </a:p>
         </p:txBody>
@@ -798,7 +799,7 @@
           <a:lstStyle/>
           <a:p>
             <a:r>
-              <a:t>Honest multi-dimensional read from an operator's seat.</a:t>
+              <a:t>Show traction now; scale only on proof.</a:t>
             </a:r>
           </a:p>
         </p:txBody>
@@ -868,7 +869,7 @@
           <a:lstStyle/>
           <a:p>
             <a:r>
-              <a:t>Kill criteria: CAC&gt;AED25K/mandate, conversion&lt;20% with founder closing, or DLD access foreclosed.</a:t>
+              <a:t>Honest multi-dimensional read from an operator's seat.</a:t>
             </a:r>
           </a:p>
         </p:txBody>
@@ -938,7 +939,7 @@
           <a:lstStyle/>
           <a:p>
             <a:r>
-              <a:t>Founder-market fit is the story: a domain expert who shipped the tool.</a:t>
+              <a:t>Kill criteria: CAC&gt;AED25K/mandate, conversion&lt;20% with founder closing, or DLD access foreclosed.</a:t>
             </a:r>
           </a:p>
         </p:txBody>
@@ -1008,7 +1009,7 @@
           <a:lstStyle/>
           <a:p>
             <a:r>
-              <a:t>Closing line: every competitor generates data OR leads OR runs a brokerage. Elevate Homes closes the full loop — and licenses the engine.</a:t>
+              <a:t>Founder-market fit is the story: a domain expert who shipped the tool.</a:t>
             </a:r>
           </a:p>
         </p:txBody>
@@ -1078,6 +1079,76 @@
           <a:lstStyle/>
           <a:p>
             <a:r>
+              <a:t>Closing line: every competitor generates data OR leads OR runs a brokerage. Elevate Homes closes the full loop — and licenses the engine.</a:t>
+            </a:r>
+          </a:p>
+        </p:txBody>
+      </p:sp>
+      <p:sp>
+        <p:nvSpPr>
+          <p:cNvPr id="4" name="Slide Number Placeholder 3"/>
+          <p:cNvSpPr>
+            <a:spLocks noGrp="1"/>
+          </p:cNvSpPr>
+          <p:nvPr>
+            <p:ph type="sldNum" idx="5" sz="quarter"/>
+          </p:nvPr>
+        </p:nvSpPr>
+        <p:spPr/>
+      </p:sp>
+    </p:spTree>
+  </p:cSld>
+  <p:clrMapOvr>
+    <a:masterClrMapping/>
+  </p:clrMapOvr>
+</p:notes>
+</file>
+
+<file path=ppt/notesSlides/notesSlide18.xml><?xml version="1.0" encoding="utf-8"?>
+<p:notes xmlns:a="http://schemas.openxmlformats.org/drawingml/2006/main" xmlns:p="http://schemas.openxmlformats.org/presentationml/2006/main" xmlns:r="http://schemas.openxmlformats.org/officeDocument/2006/relationships">
+  <p:cSld>
+    <p:spTree>
+      <p:nvGrpSpPr>
+        <p:cNvPr id="1" name=""/>
+        <p:cNvGrpSpPr/>
+        <p:nvPr/>
+      </p:nvGrpSpPr>
+      <p:grpSpPr>
+        <a:xfrm>
+          <a:off x="0" y="0"/>
+          <a:ext cx="0" cy="0"/>
+          <a:chOff x="0" y="0"/>
+          <a:chExt cx="0" cy="0"/>
+        </a:xfrm>
+      </p:grpSpPr>
+      <p:sp>
+        <p:nvSpPr>
+          <p:cNvPr id="2" name="Slide Image Placeholder 1"/>
+          <p:cNvSpPr>
+            <a:spLocks noGrp="1"/>
+          </p:cNvSpPr>
+          <p:nvPr>
+            <p:ph type="sldImg" idx="2"/>
+          </p:nvPr>
+        </p:nvSpPr>
+        <p:spPr/>
+      </p:sp>
+      <p:sp>
+        <p:nvSpPr>
+          <p:cNvPr id="3" name="Notes Placeholder 2"/>
+          <p:cNvSpPr>
+            <a:spLocks noGrp="1"/>
+          </p:cNvSpPr>
+          <p:nvPr>
+            <p:ph type="body" idx="3" sz="quarter"/>
+          </p:nvPr>
+        </p:nvSpPr>
+        <p:spPr/>
+        <p:txBody>
+          <a:bodyPr/>
+          <a:lstStyle/>
+          <a:p>
+            <a:r>
               <a:t>Thank you. Prototype is live and clickable — happy to demo /sell, /deal-check, /crm, /report, /deck.</a:t>
             </a:r>
           </a:p>
@@ -1428,7 +1499,7 @@
           <a:lstStyle/>
           <a:p>
             <a:r>
-              <a:t>Incumbents generate data OR leads OR run a brokerage. None close the loop.</a:t>
+              <a:t>Unambiguous: green = working in the prototype today; the planned list is what we explicitly have NOT built yet.</a:t>
             </a:r>
           </a:p>
         </p:txBody>
@@ -1498,7 +1569,7 @@
           <a:lstStyle/>
           <a:p>
             <a:r>
-              <a:t>Brokerage-first execution, blended monetization, dual exit. Don't make SaaS load-bearing in Year 1.</a:t>
+              <a:t>Incumbents generate data OR leads OR run a brokerage. None close the loop.</a:t>
             </a:r>
           </a:p>
         </p:txBody>
@@ -1568,7 +1639,7 @@
           <a:lstStyle/>
           <a:p>
             <a:r>
-              <a:t>Be honest: conversion % are assumptions. The model survives worse numbers because the fixed base is one salary.</a:t>
+              <a:t>Brokerage-first execution, blended monetization, dual exit. Don't make SaaS load-bearing in Year 1.</a:t>
             </a:r>
           </a:p>
         </p:txBody>
@@ -1638,7 +1709,7 @@
           <a:lstStyle/>
           <a:p>
             <a:r>
-              <a:t>Forward projections; multiples illustrative, not a quote.</a:t>
+              <a:t>Be honest: conversion % are assumptions. The model survives worse numbers because the fixed base is one salary.</a:t>
             </a:r>
           </a:p>
         </p:txBody>
@@ -4814,6 +4885,887 @@
                 </a:solidFill>
                 <a:latin typeface="Manrope"/>
               </a:rPr>
+              <a:t>FINANCIAL MODEL · 3 YEARS</a:t>
+            </a:r>
+          </a:p>
+          <a:p>
+            <a:pPr algn="l">
+              <a:lnSpc>
+                <a:spcPct val="100000"/>
+              </a:lnSpc>
+              <a:spcAft>
+                <a:spcPts val="200"/>
+              </a:spcAft>
+            </a:pPr>
+            <a:r>
+              <a:rPr sz="3400" b="1" i="0">
+                <a:solidFill>
+                  <a:srgbClr val="E8D5A3"/>
+                </a:solidFill>
+                <a:latin typeface="Cormorant Garamond"/>
+              </a:rPr>
+              <a:t>Capital-Light. Cash-Positive Fast.</a:t>
+            </a:r>
+          </a:p>
+        </p:txBody>
+      </p:sp>
+      <p:sp>
+        <p:nvSpPr>
+          <p:cNvPr id="3" name="Rounded Rectangle 2"/>
+          <p:cNvSpPr/>
+          <p:nvPr/>
+        </p:nvSpPr>
+        <p:spPr>
+          <a:xfrm>
+            <a:off x="640080" y="2103120"/>
+            <a:ext cx="3474720" cy="1554480"/>
+          </a:xfrm>
+          <a:prstGeom prst="roundRect">
+            <a:avLst/>
+          </a:prstGeom>
+          <a:solidFill>
+            <a:srgbClr val="161F2B"/>
+          </a:solidFill>
+          <a:ln w="9525">
+            <a:solidFill>
+              <a:srgbClr val="C9A84C"/>
+            </a:solidFill>
+          </a:ln>
+          <a:effectLst/>
+        </p:spPr>
+        <p:style>
+          <a:lnRef idx="1">
+            <a:schemeClr val="accent1"/>
+          </a:lnRef>
+          <a:fillRef idx="3">
+            <a:schemeClr val="accent1"/>
+          </a:fillRef>
+          <a:effectRef idx="2">
+            <a:schemeClr val="accent1"/>
+          </a:effectRef>
+          <a:fontRef idx="minor">
+            <a:schemeClr val="lt1"/>
+          </a:fontRef>
+        </p:style>
+        <p:txBody>
+          <a:bodyPr rtlCol="0" anchor="ctr"/>
+          <a:lstStyle/>
+          <a:p>
+            <a:pPr algn="ctr"/>
+          </a:p>
+        </p:txBody>
+      </p:sp>
+      <p:sp>
+        <p:nvSpPr>
+          <p:cNvPr id="4" name="TextBox 3"/>
+          <p:cNvSpPr txBox="1"/>
+          <p:nvPr/>
+        </p:nvSpPr>
+        <p:spPr>
+          <a:xfrm>
+            <a:off x="640080" y="2286000"/>
+            <a:ext cx="3474720" cy="1188719"/>
+          </a:xfrm>
+          <a:prstGeom prst="rect">
+            <a:avLst/>
+          </a:prstGeom>
+          <a:noFill/>
+        </p:spPr>
+        <p:txBody>
+          <a:bodyPr wrap="square" anchor="ctr">
+            <a:spAutoFit/>
+          </a:bodyPr>
+          <a:lstStyle/>
+          <a:p>
+            <a:pPr algn="ctr">
+              <a:lnSpc>
+                <a:spcPct val="105000"/>
+              </a:lnSpc>
+              <a:spcAft>
+                <a:spcPts val="400"/>
+              </a:spcAft>
+            </a:pPr>
+            <a:r>
+              <a:rPr sz="3000" b="1" i="0">
+                <a:solidFill>
+                  <a:srgbClr val="C9A84C"/>
+                </a:solidFill>
+                <a:latin typeface="Cormorant Garamond"/>
+              </a:rPr>
+              <a:t>AED 3.56M</a:t>
+            </a:r>
+          </a:p>
+          <a:p>
+            <a:pPr algn="ctr">
+              <a:lnSpc>
+                <a:spcPct val="105000"/>
+              </a:lnSpc>
+              <a:spcAft>
+                <a:spcPts val="200"/>
+              </a:spcAft>
+            </a:pPr>
+            <a:r>
+              <a:rPr sz="1050" b="1" i="0">
+                <a:solidFill>
+                  <a:srgbClr val="7A6F5E"/>
+                </a:solidFill>
+                <a:latin typeface="Manrope"/>
+              </a:rPr>
+              <a:t>YEAR 1 REVENUE</a:t>
+            </a:r>
+          </a:p>
+          <a:p>
+            <a:pPr algn="ctr">
+              <a:lnSpc>
+                <a:spcPct val="105000"/>
+              </a:lnSpc>
+              <a:spcAft>
+                <a:spcPts val="0"/>
+              </a:spcAft>
+            </a:pPr>
+            <a:r>
+              <a:rPr sz="1000" b="0" i="0">
+                <a:solidFill>
+                  <a:srgbClr val="C2B89A"/>
+                </a:solidFill>
+                <a:latin typeface="Manrope"/>
+              </a:rPr>
+              <a:t>EBITDA 1.75M · 49%</a:t>
+            </a:r>
+          </a:p>
+        </p:txBody>
+      </p:sp>
+      <p:sp>
+        <p:nvSpPr>
+          <p:cNvPr id="5" name="Rounded Rectangle 4"/>
+          <p:cNvSpPr/>
+          <p:nvPr/>
+        </p:nvSpPr>
+        <p:spPr>
+          <a:xfrm>
+            <a:off x="4389120" y="2103120"/>
+            <a:ext cx="3474720" cy="1554480"/>
+          </a:xfrm>
+          <a:prstGeom prst="roundRect">
+            <a:avLst/>
+          </a:prstGeom>
+          <a:solidFill>
+            <a:srgbClr val="161F2B"/>
+          </a:solidFill>
+          <a:ln w="9525">
+            <a:solidFill>
+              <a:srgbClr val="C9A84C"/>
+            </a:solidFill>
+          </a:ln>
+          <a:effectLst/>
+        </p:spPr>
+        <p:style>
+          <a:lnRef idx="1">
+            <a:schemeClr val="accent1"/>
+          </a:lnRef>
+          <a:fillRef idx="3">
+            <a:schemeClr val="accent1"/>
+          </a:fillRef>
+          <a:effectRef idx="2">
+            <a:schemeClr val="accent1"/>
+          </a:effectRef>
+          <a:fontRef idx="minor">
+            <a:schemeClr val="lt1"/>
+          </a:fontRef>
+        </p:style>
+        <p:txBody>
+          <a:bodyPr rtlCol="0" anchor="ctr"/>
+          <a:lstStyle/>
+          <a:p>
+            <a:pPr algn="ctr"/>
+          </a:p>
+        </p:txBody>
+      </p:sp>
+      <p:sp>
+        <p:nvSpPr>
+          <p:cNvPr id="6" name="TextBox 5"/>
+          <p:cNvSpPr txBox="1"/>
+          <p:nvPr/>
+        </p:nvSpPr>
+        <p:spPr>
+          <a:xfrm>
+            <a:off x="4389120" y="2286000"/>
+            <a:ext cx="3474720" cy="1188719"/>
+          </a:xfrm>
+          <a:prstGeom prst="rect">
+            <a:avLst/>
+          </a:prstGeom>
+          <a:noFill/>
+        </p:spPr>
+        <p:txBody>
+          <a:bodyPr wrap="square" anchor="ctr">
+            <a:spAutoFit/>
+          </a:bodyPr>
+          <a:lstStyle/>
+          <a:p>
+            <a:pPr algn="ctr">
+              <a:lnSpc>
+                <a:spcPct val="105000"/>
+              </a:lnSpc>
+              <a:spcAft>
+                <a:spcPts val="400"/>
+              </a:spcAft>
+            </a:pPr>
+            <a:r>
+              <a:rPr sz="3000" b="1" i="0">
+                <a:solidFill>
+                  <a:srgbClr val="C9A84C"/>
+                </a:solidFill>
+                <a:latin typeface="Cormorant Garamond"/>
+              </a:rPr>
+              <a:t>AED 10.07M</a:t>
+            </a:r>
+          </a:p>
+          <a:p>
+            <a:pPr algn="ctr">
+              <a:lnSpc>
+                <a:spcPct val="105000"/>
+              </a:lnSpc>
+              <a:spcAft>
+                <a:spcPts val="200"/>
+              </a:spcAft>
+            </a:pPr>
+            <a:r>
+              <a:rPr sz="1050" b="1" i="0">
+                <a:solidFill>
+                  <a:srgbClr val="7A6F5E"/>
+                </a:solidFill>
+                <a:latin typeface="Manrope"/>
+              </a:rPr>
+              <a:t>YEAR 2 REVENUE</a:t>
+            </a:r>
+          </a:p>
+          <a:p>
+            <a:pPr algn="ctr">
+              <a:lnSpc>
+                <a:spcPct val="105000"/>
+              </a:lnSpc>
+              <a:spcAft>
+                <a:spcPts val="0"/>
+              </a:spcAft>
+            </a:pPr>
+            <a:r>
+              <a:rPr sz="1000" b="0" i="0">
+                <a:solidFill>
+                  <a:srgbClr val="C2B89A"/>
+                </a:solidFill>
+                <a:latin typeface="Manrope"/>
+              </a:rPr>
+              <a:t>EBITDA 6.53M · 65%</a:t>
+            </a:r>
+          </a:p>
+        </p:txBody>
+      </p:sp>
+      <p:sp>
+        <p:nvSpPr>
+          <p:cNvPr id="7" name="Rounded Rectangle 6"/>
+          <p:cNvSpPr/>
+          <p:nvPr/>
+        </p:nvSpPr>
+        <p:spPr>
+          <a:xfrm>
+            <a:off x="8138160" y="2103120"/>
+            <a:ext cx="3474720" cy="1554480"/>
+          </a:xfrm>
+          <a:prstGeom prst="roundRect">
+            <a:avLst/>
+          </a:prstGeom>
+          <a:solidFill>
+            <a:srgbClr val="161F2B"/>
+          </a:solidFill>
+          <a:ln w="9525">
+            <a:solidFill>
+              <a:srgbClr val="C9A84C"/>
+            </a:solidFill>
+          </a:ln>
+          <a:effectLst/>
+        </p:spPr>
+        <p:style>
+          <a:lnRef idx="1">
+            <a:schemeClr val="accent1"/>
+          </a:lnRef>
+          <a:fillRef idx="3">
+            <a:schemeClr val="accent1"/>
+          </a:fillRef>
+          <a:effectRef idx="2">
+            <a:schemeClr val="accent1"/>
+          </a:effectRef>
+          <a:fontRef idx="minor">
+            <a:schemeClr val="lt1"/>
+          </a:fontRef>
+        </p:style>
+        <p:txBody>
+          <a:bodyPr rtlCol="0" anchor="ctr"/>
+          <a:lstStyle/>
+          <a:p>
+            <a:pPr algn="ctr"/>
+          </a:p>
+        </p:txBody>
+      </p:sp>
+      <p:sp>
+        <p:nvSpPr>
+          <p:cNvPr id="8" name="TextBox 7"/>
+          <p:cNvSpPr txBox="1"/>
+          <p:nvPr/>
+        </p:nvSpPr>
+        <p:spPr>
+          <a:xfrm>
+            <a:off x="8138160" y="2286000"/>
+            <a:ext cx="3474720" cy="1188719"/>
+          </a:xfrm>
+          <a:prstGeom prst="rect">
+            <a:avLst/>
+          </a:prstGeom>
+          <a:noFill/>
+        </p:spPr>
+        <p:txBody>
+          <a:bodyPr wrap="square" anchor="ctr">
+            <a:spAutoFit/>
+          </a:bodyPr>
+          <a:lstStyle/>
+          <a:p>
+            <a:pPr algn="ctr">
+              <a:lnSpc>
+                <a:spcPct val="105000"/>
+              </a:lnSpc>
+              <a:spcAft>
+                <a:spcPts val="400"/>
+              </a:spcAft>
+            </a:pPr>
+            <a:r>
+              <a:rPr sz="3000" b="1" i="0">
+                <a:solidFill>
+                  <a:srgbClr val="C9A84C"/>
+                </a:solidFill>
+                <a:latin typeface="Cormorant Garamond"/>
+              </a:rPr>
+              <a:t>AED 19.98M</a:t>
+            </a:r>
+          </a:p>
+          <a:p>
+            <a:pPr algn="ctr">
+              <a:lnSpc>
+                <a:spcPct val="105000"/>
+              </a:lnSpc>
+              <a:spcAft>
+                <a:spcPts val="200"/>
+              </a:spcAft>
+            </a:pPr>
+            <a:r>
+              <a:rPr sz="1050" b="1" i="0">
+                <a:solidFill>
+                  <a:srgbClr val="7A6F5E"/>
+                </a:solidFill>
+                <a:latin typeface="Manrope"/>
+              </a:rPr>
+              <a:t>YEAR 3 REVENUE</a:t>
+            </a:r>
+          </a:p>
+          <a:p>
+            <a:pPr algn="ctr">
+              <a:lnSpc>
+                <a:spcPct val="105000"/>
+              </a:lnSpc>
+              <a:spcAft>
+                <a:spcPts val="0"/>
+              </a:spcAft>
+            </a:pPr>
+            <a:r>
+              <a:rPr sz="1000" b="0" i="0">
+                <a:solidFill>
+                  <a:srgbClr val="C2B89A"/>
+                </a:solidFill>
+                <a:latin typeface="Manrope"/>
+              </a:rPr>
+              <a:t>EBITDA 15.12M · 76%</a:t>
+            </a:r>
+          </a:p>
+        </p:txBody>
+      </p:sp>
+      <p:sp>
+        <p:nvSpPr>
+          <p:cNvPr id="9" name="Rounded Rectangle 8"/>
+          <p:cNvSpPr/>
+          <p:nvPr/>
+        </p:nvSpPr>
+        <p:spPr>
+          <a:xfrm>
+            <a:off x="640080" y="4023360"/>
+            <a:ext cx="3566160" cy="2011680"/>
+          </a:xfrm>
+          <a:prstGeom prst="roundRect">
+            <a:avLst/>
+          </a:prstGeom>
+          <a:solidFill>
+            <a:srgbClr val="161F2B"/>
+          </a:solidFill>
+          <a:ln w="9525">
+            <a:solidFill>
+              <a:srgbClr val="C9A84C"/>
+            </a:solidFill>
+          </a:ln>
+          <a:effectLst/>
+        </p:spPr>
+        <p:style>
+          <a:lnRef idx="1">
+            <a:schemeClr val="accent1"/>
+          </a:lnRef>
+          <a:fillRef idx="3">
+            <a:schemeClr val="accent1"/>
+          </a:fillRef>
+          <a:effectRef idx="2">
+            <a:schemeClr val="accent1"/>
+          </a:effectRef>
+          <a:fontRef idx="minor">
+            <a:schemeClr val="lt1"/>
+          </a:fontRef>
+        </p:style>
+        <p:txBody>
+          <a:bodyPr rtlCol="0" anchor="ctr"/>
+          <a:lstStyle/>
+          <a:p>
+            <a:pPr algn="ctr"/>
+          </a:p>
+        </p:txBody>
+      </p:sp>
+      <p:sp>
+        <p:nvSpPr>
+          <p:cNvPr id="10" name="TextBox 9"/>
+          <p:cNvSpPr txBox="1"/>
+          <p:nvPr/>
+        </p:nvSpPr>
+        <p:spPr>
+          <a:xfrm>
+            <a:off x="868680" y="4187952"/>
+            <a:ext cx="3108960" cy="1682496"/>
+          </a:xfrm>
+          <a:prstGeom prst="rect">
+            <a:avLst/>
+          </a:prstGeom>
+          <a:noFill/>
+        </p:spPr>
+        <p:txBody>
+          <a:bodyPr wrap="square" anchor="t">
+            <a:spAutoFit/>
+          </a:bodyPr>
+          <a:lstStyle/>
+          <a:p>
+            <a:pPr algn="l">
+              <a:lnSpc>
+                <a:spcPct val="105000"/>
+              </a:lnSpc>
+              <a:spcAft>
+                <a:spcPts val="600"/>
+              </a:spcAft>
+            </a:pPr>
+            <a:r>
+              <a:rPr sz="1400" b="1" i="0">
+                <a:solidFill>
+                  <a:srgbClr val="E8D5A3"/>
+                </a:solidFill>
+                <a:latin typeface="Manrope"/>
+              </a:rPr>
+              <a:t>Two arms</a:t>
+            </a:r>
+          </a:p>
+          <a:p>
+            <a:pPr algn="l">
+              <a:lnSpc>
+                <a:spcPct val="105000"/>
+              </a:lnSpc>
+              <a:spcAft>
+                <a:spcPts val="400"/>
+              </a:spcAft>
+            </a:pPr>
+            <a:r>
+              <a:rPr sz="1150" b="0" i="0">
+                <a:solidFill>
+                  <a:srgbClr val="C2B89A"/>
+                </a:solidFill>
+                <a:latin typeface="Manrope"/>
+              </a:rPr>
+              <a:t>Brokerage = GCI (~98% gross).</a:t>
+            </a:r>
+          </a:p>
+          <a:p>
+            <a:pPr algn="l">
+              <a:lnSpc>
+                <a:spcPct val="105000"/>
+              </a:lnSpc>
+              <a:spcAft>
+                <a:spcPts val="400"/>
+              </a:spcAft>
+            </a:pPr>
+            <a:r>
+              <a:rPr sz="1150" b="0" i="0">
+                <a:solidFill>
+                  <a:srgbClr val="C2B89A"/>
+                </a:solidFill>
+                <a:latin typeface="Manrope"/>
+              </a:rPr>
+              <a:t>SaaS COGS only AED 120K -&gt; 264K.</a:t>
+            </a:r>
+          </a:p>
+        </p:txBody>
+      </p:sp>
+      <p:sp>
+        <p:nvSpPr>
+          <p:cNvPr id="11" name="Rounded Rectangle 10"/>
+          <p:cNvSpPr/>
+          <p:nvPr/>
+        </p:nvSpPr>
+        <p:spPr>
+          <a:xfrm>
+            <a:off x="4343400" y="4023360"/>
+            <a:ext cx="3566160" cy="2011680"/>
+          </a:xfrm>
+          <a:prstGeom prst="roundRect">
+            <a:avLst/>
+          </a:prstGeom>
+          <a:solidFill>
+            <a:srgbClr val="161F2B"/>
+          </a:solidFill>
+          <a:ln w="9525">
+            <a:solidFill>
+              <a:srgbClr val="C9A84C"/>
+            </a:solidFill>
+          </a:ln>
+          <a:effectLst/>
+        </p:spPr>
+        <p:style>
+          <a:lnRef idx="1">
+            <a:schemeClr val="accent1"/>
+          </a:lnRef>
+          <a:fillRef idx="3">
+            <a:schemeClr val="accent1"/>
+          </a:fillRef>
+          <a:effectRef idx="2">
+            <a:schemeClr val="accent1"/>
+          </a:effectRef>
+          <a:fontRef idx="minor">
+            <a:schemeClr val="lt1"/>
+          </a:fontRef>
+        </p:style>
+        <p:txBody>
+          <a:bodyPr rtlCol="0" anchor="ctr"/>
+          <a:lstStyle/>
+          <a:p>
+            <a:pPr algn="ctr"/>
+          </a:p>
+        </p:txBody>
+      </p:sp>
+      <p:sp>
+        <p:nvSpPr>
+          <p:cNvPr id="12" name="TextBox 11"/>
+          <p:cNvSpPr txBox="1"/>
+          <p:nvPr/>
+        </p:nvSpPr>
+        <p:spPr>
+          <a:xfrm>
+            <a:off x="4572000" y="4187952"/>
+            <a:ext cx="3108960" cy="1682496"/>
+          </a:xfrm>
+          <a:prstGeom prst="rect">
+            <a:avLst/>
+          </a:prstGeom>
+          <a:noFill/>
+        </p:spPr>
+        <p:txBody>
+          <a:bodyPr wrap="square" anchor="t">
+            <a:spAutoFit/>
+          </a:bodyPr>
+          <a:lstStyle/>
+          <a:p>
+            <a:pPr algn="l">
+              <a:lnSpc>
+                <a:spcPct val="105000"/>
+              </a:lnSpc>
+              <a:spcAft>
+                <a:spcPts val="600"/>
+              </a:spcAft>
+            </a:pPr>
+            <a:r>
+              <a:rPr sz="1400" b="1" i="0">
+                <a:solidFill>
+                  <a:srgbClr val="E8D5A3"/>
+                </a:solidFill>
+                <a:latin typeface="Manrope"/>
+              </a:rPr>
+              <a:t>Breakeven</a:t>
+            </a:r>
+          </a:p>
+          <a:p>
+            <a:pPr algn="l">
+              <a:lnSpc>
+                <a:spcPct val="105000"/>
+              </a:lnSpc>
+              <a:spcAft>
+                <a:spcPts val="400"/>
+              </a:spcAft>
+            </a:pPr>
+            <a:r>
+              <a:rPr sz="1150" b="0" i="0">
+                <a:solidFill>
+                  <a:srgbClr val="C2B89A"/>
+                </a:solidFill>
+                <a:latin typeface="Manrope"/>
+              </a:rPr>
+              <a:t>Brokerage ~M7 (GCI carries Y1).</a:t>
+            </a:r>
+          </a:p>
+          <a:p>
+            <a:pPr algn="l">
+              <a:lnSpc>
+                <a:spcPct val="105000"/>
+              </a:lnSpc>
+              <a:spcAft>
+                <a:spcPts val="400"/>
+              </a:spcAft>
+            </a:pPr>
+            <a:r>
+              <a:rPr sz="1150" b="0" i="0">
+                <a:solidFill>
+                  <a:srgbClr val="C2B89A"/>
+                </a:solidFill>
+                <a:latin typeface="Manrope"/>
+              </a:rPr>
+              <a:t>SaaS self-sustaining ~M18.</a:t>
+            </a:r>
+          </a:p>
+          <a:p>
+            <a:pPr algn="l">
+              <a:lnSpc>
+                <a:spcPct val="105000"/>
+              </a:lnSpc>
+              <a:spcAft>
+                <a:spcPts val="400"/>
+              </a:spcAft>
+            </a:pPr>
+            <a:r>
+              <a:rPr sz="1150" b="0" i="0">
+                <a:solidFill>
+                  <a:srgbClr val="C2B89A"/>
+                </a:solidFill>
+                <a:latin typeface="Manrope"/>
+              </a:rPr>
+              <a:t>Positive EBITDA from Year 2.</a:t>
+            </a:r>
+          </a:p>
+        </p:txBody>
+      </p:sp>
+      <p:sp>
+        <p:nvSpPr>
+          <p:cNvPr id="13" name="Rounded Rectangle 12"/>
+          <p:cNvSpPr/>
+          <p:nvPr/>
+        </p:nvSpPr>
+        <p:spPr>
+          <a:xfrm>
+            <a:off x="8046720" y="4023360"/>
+            <a:ext cx="3520440" cy="2011680"/>
+          </a:xfrm>
+          <a:prstGeom prst="roundRect">
+            <a:avLst/>
+          </a:prstGeom>
+          <a:solidFill>
+            <a:srgbClr val="161F2B"/>
+          </a:solidFill>
+          <a:ln w="9525">
+            <a:solidFill>
+              <a:srgbClr val="C9A84C"/>
+            </a:solidFill>
+          </a:ln>
+          <a:effectLst/>
+        </p:spPr>
+        <p:style>
+          <a:lnRef idx="1">
+            <a:schemeClr val="accent1"/>
+          </a:lnRef>
+          <a:fillRef idx="3">
+            <a:schemeClr val="accent1"/>
+          </a:fillRef>
+          <a:effectRef idx="2">
+            <a:schemeClr val="accent1"/>
+          </a:effectRef>
+          <a:fontRef idx="minor">
+            <a:schemeClr val="lt1"/>
+          </a:fontRef>
+        </p:style>
+        <p:txBody>
+          <a:bodyPr rtlCol="0" anchor="ctr"/>
+          <a:lstStyle/>
+          <a:p>
+            <a:pPr algn="ctr"/>
+          </a:p>
+        </p:txBody>
+      </p:sp>
+      <p:sp>
+        <p:nvSpPr>
+          <p:cNvPr id="14" name="TextBox 13"/>
+          <p:cNvSpPr txBox="1"/>
+          <p:nvPr/>
+        </p:nvSpPr>
+        <p:spPr>
+          <a:xfrm>
+            <a:off x="8275320" y="4187952"/>
+            <a:ext cx="3063240" cy="1682496"/>
+          </a:xfrm>
+          <a:prstGeom prst="rect">
+            <a:avLst/>
+          </a:prstGeom>
+          <a:noFill/>
+        </p:spPr>
+        <p:txBody>
+          <a:bodyPr wrap="square" anchor="t">
+            <a:spAutoFit/>
+          </a:bodyPr>
+          <a:lstStyle/>
+          <a:p>
+            <a:pPr algn="l">
+              <a:lnSpc>
+                <a:spcPct val="105000"/>
+              </a:lnSpc>
+              <a:spcAft>
+                <a:spcPts val="600"/>
+              </a:spcAft>
+            </a:pPr>
+            <a:r>
+              <a:rPr sz="1400" b="1" i="0">
+                <a:solidFill>
+                  <a:srgbClr val="E8D5A3"/>
+                </a:solidFill>
+                <a:latin typeface="Manrope"/>
+              </a:rPr>
+              <a:t>Indicative Y3 value</a:t>
+            </a:r>
+          </a:p>
+          <a:p>
+            <a:pPr algn="l">
+              <a:lnSpc>
+                <a:spcPct val="105000"/>
+              </a:lnSpc>
+              <a:spcAft>
+                <a:spcPts val="400"/>
+              </a:spcAft>
+            </a:pPr>
+            <a:r>
+              <a:rPr sz="1150" b="0" i="0">
+                <a:solidFill>
+                  <a:srgbClr val="C2B89A"/>
+                </a:solidFill>
+                <a:latin typeface="Manrope"/>
+              </a:rPr>
+              <a:t>SaaS ~1.85M ARR x ~10x</a:t>
+            </a:r>
+          </a:p>
+          <a:p>
+            <a:pPr algn="l">
+              <a:lnSpc>
+                <a:spcPct val="105000"/>
+              </a:lnSpc>
+              <a:spcAft>
+                <a:spcPts val="400"/>
+              </a:spcAft>
+            </a:pPr>
+            <a:r>
+              <a:rPr sz="1150" b="0" i="0">
+                <a:solidFill>
+                  <a:srgbClr val="C2B89A"/>
+                </a:solidFill>
+                <a:latin typeface="Manrope"/>
+              </a:rPr>
+              <a:t>+ brokerage EBITDA x ~4x</a:t>
+            </a:r>
+          </a:p>
+          <a:p>
+            <a:pPr algn="l">
+              <a:lnSpc>
+                <a:spcPct val="105000"/>
+              </a:lnSpc>
+              <a:spcAft>
+                <a:spcPts val="400"/>
+              </a:spcAft>
+            </a:pPr>
+            <a:r>
+              <a:rPr sz="1150" b="0" i="0">
+                <a:solidFill>
+                  <a:srgbClr val="C2B89A"/>
+                </a:solidFill>
+                <a:latin typeface="Manrope"/>
+              </a:rPr>
+              <a:t>-&gt; ~AED 40-60M · dual exit</a:t>
+            </a:r>
+          </a:p>
+        </p:txBody>
+      </p:sp>
+    </p:spTree>
+  </p:cSld>
+  <p:clrMapOvr>
+    <a:masterClrMapping/>
+  </p:clrMapOvr>
+</p:sld>
+</file>
+
+<file path=ppt/slides/slide11.xml><?xml version="1.0" encoding="utf-8"?>
+<p:sld xmlns:a="http://schemas.openxmlformats.org/drawingml/2006/main" xmlns:p="http://schemas.openxmlformats.org/presentationml/2006/main" xmlns:r="http://schemas.openxmlformats.org/officeDocument/2006/relationships">
+  <p:cSld>
+    <p:bg>
+      <p:bgPr>
+        <a:solidFill>
+          <a:srgbClr val="0C1118"/>
+        </a:solidFill>
+        <a:effectLst/>
+      </p:bgPr>
+    </p:bg>
+    <p:spTree>
+      <p:nvGrpSpPr>
+        <p:cNvPr id="1" name=""/>
+        <p:cNvGrpSpPr/>
+        <p:nvPr/>
+      </p:nvGrpSpPr>
+      <p:grpSpPr/>
+      <p:sp>
+        <p:nvSpPr>
+          <p:cNvPr id="2" name="TextBox 1"/>
+          <p:cNvSpPr txBox="1"/>
+          <p:nvPr/>
+        </p:nvSpPr>
+        <p:spPr>
+          <a:xfrm>
+            <a:off x="640080" y="502920"/>
+            <a:ext cx="10972800" cy="1554480"/>
+          </a:xfrm>
+          <a:prstGeom prst="rect">
+            <a:avLst/>
+          </a:prstGeom>
+          <a:noFill/>
+        </p:spPr>
+        <p:txBody>
+          <a:bodyPr wrap="square" anchor="t">
+            <a:spAutoFit/>
+          </a:bodyPr>
+          <a:lstStyle/>
+          <a:p>
+            <a:pPr algn="l">
+              <a:lnSpc>
+                <a:spcPct val="105000"/>
+              </a:lnSpc>
+              <a:spcAft>
+                <a:spcPts val="600"/>
+              </a:spcAft>
+            </a:pPr>
+            <a:r>
+              <a:rPr sz="1200" b="1" i="0">
+                <a:solidFill>
+                  <a:srgbClr val="C9A84C"/>
+                </a:solidFill>
+                <a:latin typeface="Manrope"/>
+              </a:rPr>
               <a:t>SCALABILITY · THE FLYWHEEL</a:t>
             </a:r>
           </a:p>
@@ -5342,7 +6294,7 @@
 </p:sld>
 </file>
 
-<file path=ppt/slides/slide11.xml><?xml version="1.0" encoding="utf-8"?>
+<file path=ppt/slides/slide12.xml><?xml version="1.0" encoding="utf-8"?>
 <p:sld xmlns:a="http://schemas.openxmlformats.org/drawingml/2006/main" xmlns:p="http://schemas.openxmlformats.org/presentationml/2006/main" xmlns:r="http://schemas.openxmlformats.org/officeDocument/2006/relationships">
   <p:cSld>
     <p:bg>
@@ -5857,7 +6809,7 @@
 </p:sld>
 </file>
 
-<file path=ppt/slides/slide12.xml><?xml version="1.0" encoding="utf-8"?>
+<file path=ppt/slides/slide13.xml><?xml version="1.0" encoding="utf-8"?>
 <p:sld xmlns:a="http://schemas.openxmlformats.org/drawingml/2006/main" xmlns:p="http://schemas.openxmlformats.org/presentationml/2006/main" xmlns:r="http://schemas.openxmlformats.org/officeDocument/2006/relationships">
   <p:cSld>
     <p:bg>
@@ -6322,7 +7274,7 @@
 </p:sld>
 </file>
 
-<file path=ppt/slides/slide13.xml><?xml version="1.0" encoding="utf-8"?>
+<file path=ppt/slides/slide14.xml><?xml version="1.0" encoding="utf-8"?>
 <p:sld xmlns:a="http://schemas.openxmlformats.org/drawingml/2006/main" xmlns:p="http://schemas.openxmlformats.org/presentationml/2006/main" xmlns:r="http://schemas.openxmlformats.org/officeDocument/2006/relationships">
   <p:cSld>
     <p:bg>
@@ -7051,7 +8003,7 @@
 </p:sld>
 </file>
 
-<file path=ppt/slides/slide14.xml><?xml version="1.0" encoding="utf-8"?>
+<file path=ppt/slides/slide15.xml><?xml version="1.0" encoding="utf-8"?>
 <p:sld xmlns:a="http://schemas.openxmlformats.org/drawingml/2006/main" xmlns:p="http://schemas.openxmlformats.org/presentationml/2006/main" xmlns:r="http://schemas.openxmlformats.org/officeDocument/2006/relationships">
   <p:cSld>
     <p:bg>
@@ -7528,7 +8480,7 @@
 </p:sld>
 </file>
 
-<file path=ppt/slides/slide15.xml><?xml version="1.0" encoding="utf-8"?>
+<file path=ppt/slides/slide16.xml><?xml version="1.0" encoding="utf-8"?>
 <p:sld xmlns:a="http://schemas.openxmlformats.org/drawingml/2006/main" xmlns:p="http://schemas.openxmlformats.org/presentationml/2006/main" xmlns:r="http://schemas.openxmlformats.org/officeDocument/2006/relationships">
   <p:cSld>
     <p:bg>
@@ -8195,7 +9147,7 @@
 </p:sld>
 </file>
 
-<file path=ppt/slides/slide16.xml><?xml version="1.0" encoding="utf-8"?>
+<file path=ppt/slides/slide17.xml><?xml version="1.0" encoding="utf-8"?>
 <p:sld xmlns:a="http://schemas.openxmlformats.org/drawingml/2006/main" xmlns:p="http://schemas.openxmlformats.org/presentationml/2006/main" xmlns:r="http://schemas.openxmlformats.org/officeDocument/2006/relationships">
   <p:cSld>
     <p:bg>
@@ -8969,7 +9921,7 @@
 </p:sld>
 </file>
 
-<file path=ppt/slides/slide17.xml><?xml version="1.0" encoding="utf-8"?>
+<file path=ppt/slides/slide18.xml><?xml version="1.0" encoding="utf-8"?>
 <p:sld xmlns:a="http://schemas.openxmlformats.org/drawingml/2006/main" xmlns:p="http://schemas.openxmlformats.org/presentationml/2006/main" xmlns:r="http://schemas.openxmlformats.org/officeDocument/2006/relationships">
   <p:cSld>
     <p:bg>
@@ -12305,6 +13257,888 @@
 </file>
 
 <file path=ppt/slides/slide6.xml><?xml version="1.0" encoding="utf-8"?>
+<p:sld xmlns:a="http://schemas.openxmlformats.org/drawingml/2006/main" xmlns:p="http://schemas.openxmlformats.org/presentationml/2006/main" xmlns:r="http://schemas.openxmlformats.org/officeDocument/2006/relationships">
+  <p:cSld>
+    <p:bg>
+      <p:bgPr>
+        <a:solidFill>
+          <a:srgbClr val="0C1118"/>
+        </a:solidFill>
+        <a:effectLst/>
+      </p:bgPr>
+    </p:bg>
+    <p:spTree>
+      <p:nvGrpSpPr>
+        <p:cNvPr id="1" name=""/>
+        <p:cNvGrpSpPr/>
+        <p:nvPr/>
+      </p:nvGrpSpPr>
+      <p:grpSpPr/>
+      <p:sp>
+        <p:nvSpPr>
+          <p:cNvPr id="2" name="TextBox 1"/>
+          <p:cNvSpPr txBox="1"/>
+          <p:nvPr/>
+        </p:nvSpPr>
+        <p:spPr>
+          <a:xfrm>
+            <a:off x="640080" y="502920"/>
+            <a:ext cx="10972800" cy="1554480"/>
+          </a:xfrm>
+          <a:prstGeom prst="rect">
+            <a:avLst/>
+          </a:prstGeom>
+          <a:noFill/>
+        </p:spPr>
+        <p:txBody>
+          <a:bodyPr wrap="square" anchor="t">
+            <a:spAutoFit/>
+          </a:bodyPr>
+          <a:lstStyle/>
+          <a:p>
+            <a:pPr algn="l">
+              <a:lnSpc>
+                <a:spcPct val="105000"/>
+              </a:lnSpc>
+              <a:spcAft>
+                <a:spcPts val="600"/>
+              </a:spcAft>
+            </a:pPr>
+            <a:r>
+              <a:rPr sz="1200" b="1" i="0">
+                <a:solidFill>
+                  <a:srgbClr val="C9A84C"/>
+                </a:solidFill>
+                <a:latin typeface="Manrope"/>
+              </a:rPr>
+              <a:t>FEATURE LIST · NO AMBIGUITY</a:t>
+            </a:r>
+          </a:p>
+          <a:p>
+            <a:pPr algn="l">
+              <a:lnSpc>
+                <a:spcPct val="100000"/>
+              </a:lnSpc>
+              <a:spcAft>
+                <a:spcPts val="200"/>
+              </a:spcAft>
+            </a:pPr>
+            <a:r>
+              <a:rPr sz="3400" b="1" i="0">
+                <a:solidFill>
+                  <a:srgbClr val="E8D5A3"/>
+                </a:solidFill>
+                <a:latin typeface="Cormorant Garamond"/>
+              </a:rPr>
+              <a:t>Exactly What We're Building</a:t>
+            </a:r>
+          </a:p>
+        </p:txBody>
+      </p:sp>
+      <p:graphicFrame>
+        <p:nvGraphicFramePr>
+          <p:cNvPr id="3" name="Table 2"/>
+          <p:cNvGraphicFramePr>
+            <a:graphicFrameLocks noGrp="1"/>
+          </p:cNvGraphicFramePr>
+          <p:nvPr/>
+        </p:nvGraphicFramePr>
+        <p:xfrm>
+          <a:off x="640080" y="1783080"/>
+          <a:ext cx="10927080" cy="3657600"/>
+        </p:xfrm>
+        <a:graphic>
+          <a:graphicData uri="http://schemas.openxmlformats.org/drawingml/2006/table">
+            <a:tbl>
+              <a:tblPr firstRow="1" bandRow="1">
+                <a:tableStyleId>{5C22544A-7EE6-4342-B048-85BDC9FD1C3A}</a:tableStyleId>
+              </a:tblPr>
+              <a:tblGrid>
+                <a:gridCol w="2743200"/>
+                <a:gridCol w="6720840"/>
+                <a:gridCol w="1463040"/>
+              </a:tblGrid>
+              <a:tr h="365760">
+                <a:tc>
+                  <a:txBody>
+                    <a:bodyPr wrap="square"/>
+                    <a:lstStyle/>
+                    <a:p>
+                      <a:r>
+                        <a:rPr sz="950" b="1">
+                          <a:solidFill>
+                            <a:srgbClr val="C9A84C"/>
+                          </a:solidFill>
+                          <a:latin typeface="Manrope"/>
+                        </a:rPr>
+                        <a:t>Module</a:t>
+                      </a:r>
+                    </a:p>
+                  </a:txBody>
+                  <a:tcPr marL="109728" marR="73152" marT="27432" marB="27432" anchor="ctr">
+                    <a:solidFill>
+                      <a:srgbClr val="2A2412"/>
+                    </a:solidFill>
+                  </a:tcPr>
+                </a:tc>
+                <a:tc>
+                  <a:txBody>
+                    <a:bodyPr wrap="square"/>
+                    <a:lstStyle/>
+                    <a:p>
+                      <a:r>
+                        <a:rPr sz="950" b="1">
+                          <a:solidFill>
+                            <a:srgbClr val="C9A84C"/>
+                          </a:solidFill>
+                          <a:latin typeface="Manrope"/>
+                        </a:rPr>
+                        <a:t>What it does - precisely</a:t>
+                      </a:r>
+                    </a:p>
+                  </a:txBody>
+                  <a:tcPr marL="109728" marR="73152" marT="27432" marB="27432" anchor="ctr">
+                    <a:solidFill>
+                      <a:srgbClr val="2A2412"/>
+                    </a:solidFill>
+                  </a:tcPr>
+                </a:tc>
+                <a:tc>
+                  <a:txBody>
+                    <a:bodyPr wrap="square"/>
+                    <a:lstStyle/>
+                    <a:p>
+                      <a:r>
+                        <a:rPr sz="950" b="1">
+                          <a:solidFill>
+                            <a:srgbClr val="C9A84C"/>
+                          </a:solidFill>
+                          <a:latin typeface="Manrope"/>
+                        </a:rPr>
+                        <a:t>Status</a:t>
+                      </a:r>
+                    </a:p>
+                  </a:txBody>
+                  <a:tcPr marL="109728" marR="73152" marT="27432" marB="27432" anchor="ctr">
+                    <a:solidFill>
+                      <a:srgbClr val="2A2412"/>
+                    </a:solidFill>
+                  </a:tcPr>
+                </a:tc>
+              </a:tr>
+              <a:tr h="365760">
+                <a:tc>
+                  <a:txBody>
+                    <a:bodyPr wrap="square"/>
+                    <a:lstStyle/>
+                    <a:p>
+                      <a:r>
+                        <a:rPr sz="950" b="0">
+                          <a:solidFill>
+                            <a:srgbClr val="F0ECE4"/>
+                          </a:solidFill>
+                          <a:latin typeface="Manrope"/>
+                        </a:rPr>
+                        <a:t>PRISM hybrid engine</a:t>
+                      </a:r>
+                    </a:p>
+                  </a:txBody>
+                  <a:tcPr marL="109728" marR="73152" marT="27432" marB="27432" anchor="ctr">
+                    <a:solidFill>
+                      <a:srgbClr val="121820"/>
+                    </a:solidFill>
+                  </a:tcPr>
+                </a:tc>
+                <a:tc>
+                  <a:txBody>
+                    <a:bodyPr wrap="square"/>
+                    <a:lstStyle/>
+                    <a:p>
+                      <a:r>
+                        <a:rPr sz="950" b="0">
+                          <a:solidFill>
+                            <a:srgbClr val="C2B89A"/>
+                          </a:solidFill>
+                          <a:latin typeface="Manrope"/>
+                        </a:rPr>
+                        <a:t>DLD comp median + log-size 0.2733 + recency/size weighting + diagnostics</a:t>
+                      </a:r>
+                    </a:p>
+                  </a:txBody>
+                  <a:tcPr marL="109728" marR="73152" marT="27432" marB="27432" anchor="ctr">
+                    <a:solidFill>
+                      <a:srgbClr val="121820"/>
+                    </a:solidFill>
+                  </a:tcPr>
+                </a:tc>
+                <a:tc>
+                  <a:txBody>
+                    <a:bodyPr wrap="square"/>
+                    <a:lstStyle/>
+                    <a:p>
+                      <a:r>
+                        <a:rPr sz="950" b="0">
+                          <a:solidFill>
+                            <a:srgbClr val="C2B89A"/>
+                          </a:solidFill>
+                          <a:latin typeface="Manrope"/>
+                        </a:rPr>
+                        <a:t>LIVE</a:t>
+                      </a:r>
+                    </a:p>
+                  </a:txBody>
+                  <a:tcPr marL="109728" marR="73152" marT="27432" marB="27432" anchor="ctr">
+                    <a:solidFill>
+                      <a:srgbClr val="121820"/>
+                    </a:solidFill>
+                  </a:tcPr>
+                </a:tc>
+              </a:tr>
+              <a:tr h="365760">
+                <a:tc>
+                  <a:txBody>
+                    <a:bodyPr wrap="square"/>
+                    <a:lstStyle/>
+                    <a:p>
+                      <a:r>
+                        <a:rPr sz="950" b="0">
+                          <a:solidFill>
+                            <a:srgbClr val="F0ECE4"/>
+                          </a:solidFill>
+                          <a:latin typeface="Manrope"/>
+                        </a:rPr>
+                        <a:t>Seller valuation /sell</a:t>
+                      </a:r>
+                    </a:p>
+                  </a:txBody>
+                  <a:tcPr marL="109728" marR="73152" marT="27432" marB="27432" anchor="ctr">
+                    <a:solidFill>
+                      <a:srgbClr val="0F141B"/>
+                    </a:solidFill>
+                  </a:tcPr>
+                </a:tc>
+                <a:tc>
+                  <a:txBody>
+                    <a:bodyPr wrap="square"/>
+                    <a:lstStyle/>
+                    <a:p>
+                      <a:r>
+                        <a:rPr sz="950" b="0">
+                          <a:solidFill>
+                            <a:srgbClr val="C2B89A"/>
+                          </a:solidFill>
+                          <a:latin typeface="Manrope"/>
+                        </a:rPr>
+                        <a:t>Fair value, 3-tier listing range, liquidity, target-price check</a:t>
+                      </a:r>
+                    </a:p>
+                  </a:txBody>
+                  <a:tcPr marL="109728" marR="73152" marT="27432" marB="27432" anchor="ctr">
+                    <a:solidFill>
+                      <a:srgbClr val="0F141B"/>
+                    </a:solidFill>
+                  </a:tcPr>
+                </a:tc>
+                <a:tc>
+                  <a:txBody>
+                    <a:bodyPr wrap="square"/>
+                    <a:lstStyle/>
+                    <a:p>
+                      <a:r>
+                        <a:rPr sz="950" b="0">
+                          <a:solidFill>
+                            <a:srgbClr val="C2B89A"/>
+                          </a:solidFill>
+                          <a:latin typeface="Manrope"/>
+                        </a:rPr>
+                        <a:t>LIVE</a:t>
+                      </a:r>
+                    </a:p>
+                  </a:txBody>
+                  <a:tcPr marL="109728" marR="73152" marT="27432" marB="27432" anchor="ctr">
+                    <a:solidFill>
+                      <a:srgbClr val="0F141B"/>
+                    </a:solidFill>
+                  </a:tcPr>
+                </a:tc>
+              </a:tr>
+              <a:tr h="365760">
+                <a:tc>
+                  <a:txBody>
+                    <a:bodyPr wrap="square"/>
+                    <a:lstStyle/>
+                    <a:p>
+                      <a:r>
+                        <a:rPr sz="950" b="0">
+                          <a:solidFill>
+                            <a:srgbClr val="F0ECE4"/>
+                          </a:solidFill>
+                          <a:latin typeface="Manrope"/>
+                        </a:rPr>
+                        <a:t>Buyer deal-check</a:t>
+                      </a:r>
+                    </a:p>
+                  </a:txBody>
+                  <a:tcPr marL="109728" marR="73152" marT="27432" marB="27432" anchor="ctr">
+                    <a:solidFill>
+                      <a:srgbClr val="121820"/>
+                    </a:solidFill>
+                  </a:tcPr>
+                </a:tc>
+                <a:tc>
+                  <a:txBody>
+                    <a:bodyPr wrap="square"/>
+                    <a:lstStyle/>
+                    <a:p>
+                      <a:r>
+                        <a:rPr sz="950" b="0">
+                          <a:solidFill>
+                            <a:srgbClr val="C2B89A"/>
+                          </a:solidFill>
+                          <a:latin typeface="Manrope"/>
+                        </a:rPr>
+                        <a:t>Verdict (Buy/Fair/Over) + fair value + P25-P75 band position</a:t>
+                      </a:r>
+                    </a:p>
+                  </a:txBody>
+                  <a:tcPr marL="109728" marR="73152" marT="27432" marB="27432" anchor="ctr">
+                    <a:solidFill>
+                      <a:srgbClr val="121820"/>
+                    </a:solidFill>
+                  </a:tcPr>
+                </a:tc>
+                <a:tc>
+                  <a:txBody>
+                    <a:bodyPr wrap="square"/>
+                    <a:lstStyle/>
+                    <a:p>
+                      <a:r>
+                        <a:rPr sz="950" b="0">
+                          <a:solidFill>
+                            <a:srgbClr val="C2B89A"/>
+                          </a:solidFill>
+                          <a:latin typeface="Manrope"/>
+                        </a:rPr>
+                        <a:t>LIVE</a:t>
+                      </a:r>
+                    </a:p>
+                  </a:txBody>
+                  <a:tcPr marL="109728" marR="73152" marT="27432" marB="27432" anchor="ctr">
+                    <a:solidFill>
+                      <a:srgbClr val="121820"/>
+                    </a:solidFill>
+                  </a:tcPr>
+                </a:tc>
+              </a:tr>
+              <a:tr h="365760">
+                <a:tc>
+                  <a:txBody>
+                    <a:bodyPr wrap="square"/>
+                    <a:lstStyle/>
+                    <a:p>
+                      <a:r>
+                        <a:rPr sz="950" b="0">
+                          <a:solidFill>
+                            <a:srgbClr val="F0ECE4"/>
+                          </a:solidFill>
+                          <a:latin typeface="Manrope"/>
+                        </a:rPr>
+                        <a:t>Comparable transactions</a:t>
+                      </a:r>
+                    </a:p>
+                  </a:txBody>
+                  <a:tcPr marL="109728" marR="73152" marT="27432" marB="27432" anchor="ctr">
+                    <a:solidFill>
+                      <a:srgbClr val="0F141B"/>
+                    </a:solidFill>
+                  </a:tcPr>
+                </a:tc>
+                <a:tc>
+                  <a:txBody>
+                    <a:bodyPr wrap="square"/>
+                    <a:lstStyle/>
+                    <a:p>
+                      <a:r>
+                        <a:rPr sz="950" b="0">
+                          <a:solidFill>
+                            <a:srgbClr val="C2B89A"/>
+                          </a:solidFill>
+                          <a:latin typeface="Manrope"/>
+                        </a:rPr>
+                        <a:t>Actual DLD rows inline: date, project, rooms, sqft, price, AED/sqft</a:t>
+                      </a:r>
+                    </a:p>
+                  </a:txBody>
+                  <a:tcPr marL="109728" marR="73152" marT="27432" marB="27432" anchor="ctr">
+                    <a:solidFill>
+                      <a:srgbClr val="0F141B"/>
+                    </a:solidFill>
+                  </a:tcPr>
+                </a:tc>
+                <a:tc>
+                  <a:txBody>
+                    <a:bodyPr wrap="square"/>
+                    <a:lstStyle/>
+                    <a:p>
+                      <a:r>
+                        <a:rPr sz="950" b="0">
+                          <a:solidFill>
+                            <a:srgbClr val="C2B89A"/>
+                          </a:solidFill>
+                          <a:latin typeface="Manrope"/>
+                        </a:rPr>
+                        <a:t>LIVE</a:t>
+                      </a:r>
+                    </a:p>
+                  </a:txBody>
+                  <a:tcPr marL="109728" marR="73152" marT="27432" marB="27432" anchor="ctr">
+                    <a:solidFill>
+                      <a:srgbClr val="0F141B"/>
+                    </a:solidFill>
+                  </a:tcPr>
+                </a:tc>
+              </a:tr>
+              <a:tr h="365760">
+                <a:tc>
+                  <a:txBody>
+                    <a:bodyPr wrap="square"/>
+                    <a:lstStyle/>
+                    <a:p>
+                      <a:r>
+                        <a:rPr sz="950" b="0">
+                          <a:solidFill>
+                            <a:srgbClr val="F0ECE4"/>
+                          </a:solidFill>
+                          <a:latin typeface="Manrope"/>
+                        </a:rPr>
+                        <a:t>Pricing Proof report /report</a:t>
+                      </a:r>
+                    </a:p>
+                  </a:txBody>
+                  <a:tcPr marL="109728" marR="73152" marT="27432" marB="27432" anchor="ctr">
+                    <a:solidFill>
+                      <a:srgbClr val="121820"/>
+                    </a:solidFill>
+                  </a:tcPr>
+                </a:tc>
+                <a:tc>
+                  <a:txBody>
+                    <a:bodyPr wrap="square"/>
+                    <a:lstStyle/>
+                    <a:p>
+                      <a:r>
+                        <a:rPr sz="950" b="0">
+                          <a:solidFill>
+                            <a:srgbClr val="C2B89A"/>
+                          </a:solidFill>
+                          <a:latin typeface="Manrope"/>
+                        </a:rPr>
+                        <a:t>Branded print-to-PDF with comparables + methodology</a:t>
+                      </a:r>
+                    </a:p>
+                  </a:txBody>
+                  <a:tcPr marL="109728" marR="73152" marT="27432" marB="27432" anchor="ctr">
+                    <a:solidFill>
+                      <a:srgbClr val="121820"/>
+                    </a:solidFill>
+                  </a:tcPr>
+                </a:tc>
+                <a:tc>
+                  <a:txBody>
+                    <a:bodyPr wrap="square"/>
+                    <a:lstStyle/>
+                    <a:p>
+                      <a:r>
+                        <a:rPr sz="950" b="0">
+                          <a:solidFill>
+                            <a:srgbClr val="C2B89A"/>
+                          </a:solidFill>
+                          <a:latin typeface="Manrope"/>
+                        </a:rPr>
+                        <a:t>LIVE</a:t>
+                      </a:r>
+                    </a:p>
+                  </a:txBody>
+                  <a:tcPr marL="109728" marR="73152" marT="27432" marB="27432" anchor="ctr">
+                    <a:solidFill>
+                      <a:srgbClr val="121820"/>
+                    </a:solidFill>
+                  </a:tcPr>
+                </a:tc>
+              </a:tr>
+              <a:tr h="365760">
+                <a:tc>
+                  <a:txBody>
+                    <a:bodyPr wrap="square"/>
+                    <a:lstStyle/>
+                    <a:p>
+                      <a:r>
+                        <a:rPr sz="950" b="0">
+                          <a:solidFill>
+                            <a:srgbClr val="F0ECE4"/>
+                          </a:solidFill>
+                          <a:latin typeface="Manrope"/>
+                        </a:rPr>
+                        <a:t>Lead capture /api/leads</a:t>
+                      </a:r>
+                    </a:p>
+                  </a:txBody>
+                  <a:tcPr marL="109728" marR="73152" marT="27432" marB="27432" anchor="ctr">
+                    <a:solidFill>
+                      <a:srgbClr val="0F141B"/>
+                    </a:solidFill>
+                  </a:tcPr>
+                </a:tc>
+                <a:tc>
+                  <a:txBody>
+                    <a:bodyPr wrap="square"/>
+                    <a:lstStyle/>
+                    <a:p>
+                      <a:r>
+                        <a:rPr sz="950" b="0">
+                          <a:solidFill>
+                            <a:srgbClr val="C2B89A"/>
+                          </a:solidFill>
+                          <a:latin typeface="Manrope"/>
+                        </a:rPr>
+                        <a:t>Soft-gate; stores intent + property + valuation snapshot</a:t>
+                      </a:r>
+                    </a:p>
+                  </a:txBody>
+                  <a:tcPr marL="109728" marR="73152" marT="27432" marB="27432" anchor="ctr">
+                    <a:solidFill>
+                      <a:srgbClr val="0F141B"/>
+                    </a:solidFill>
+                  </a:tcPr>
+                </a:tc>
+                <a:tc>
+                  <a:txBody>
+                    <a:bodyPr wrap="square"/>
+                    <a:lstStyle/>
+                    <a:p>
+                      <a:r>
+                        <a:rPr sz="950" b="0">
+                          <a:solidFill>
+                            <a:srgbClr val="C2B89A"/>
+                          </a:solidFill>
+                          <a:latin typeface="Manrope"/>
+                        </a:rPr>
+                        <a:t>LIVE</a:t>
+                      </a:r>
+                    </a:p>
+                  </a:txBody>
+                  <a:tcPr marL="109728" marR="73152" marT="27432" marB="27432" anchor="ctr">
+                    <a:solidFill>
+                      <a:srgbClr val="0F141B"/>
+                    </a:solidFill>
+                  </a:tcPr>
+                </a:tc>
+              </a:tr>
+              <a:tr h="365760">
+                <a:tc>
+                  <a:txBody>
+                    <a:bodyPr wrap="square"/>
+                    <a:lstStyle/>
+                    <a:p>
+                      <a:r>
+                        <a:rPr sz="950" b="0">
+                          <a:solidFill>
+                            <a:srgbClr val="F0ECE4"/>
+                          </a:solidFill>
+                          <a:latin typeface="Manrope"/>
+                        </a:rPr>
+                        <a:t>Agent CRM /crm</a:t>
+                      </a:r>
+                    </a:p>
+                  </a:txBody>
+                  <a:tcPr marL="109728" marR="73152" marT="27432" marB="27432" anchor="ctr">
+                    <a:solidFill>
+                      <a:srgbClr val="121820"/>
+                    </a:solidFill>
+                  </a:tcPr>
+                </a:tc>
+                <a:tc>
+                  <a:txBody>
+                    <a:bodyPr wrap="square"/>
+                    <a:lstStyle/>
+                    <a:p>
+                      <a:r>
+                        <a:rPr sz="950" b="0">
+                          <a:solidFill>
+                            <a:srgbClr val="C2B89A"/>
+                          </a:solidFill>
+                          <a:latin typeface="Manrope"/>
+                        </a:rPr>
+                        <a:t>Pipeline New-&gt;Mandate-&gt;Closed, notes, history, stage control</a:t>
+                      </a:r>
+                    </a:p>
+                  </a:txBody>
+                  <a:tcPr marL="109728" marR="73152" marT="27432" marB="27432" anchor="ctr">
+                    <a:solidFill>
+                      <a:srgbClr val="121820"/>
+                    </a:solidFill>
+                  </a:tcPr>
+                </a:tc>
+                <a:tc>
+                  <a:txBody>
+                    <a:bodyPr wrap="square"/>
+                    <a:lstStyle/>
+                    <a:p>
+                      <a:r>
+                        <a:rPr sz="950" b="0">
+                          <a:solidFill>
+                            <a:srgbClr val="C2B89A"/>
+                          </a:solidFill>
+                          <a:latin typeface="Manrope"/>
+                        </a:rPr>
+                        <a:t>LIVE</a:t>
+                      </a:r>
+                    </a:p>
+                  </a:txBody>
+                  <a:tcPr marL="109728" marR="73152" marT="27432" marB="27432" anchor="ctr">
+                    <a:solidFill>
+                      <a:srgbClr val="121820"/>
+                    </a:solidFill>
+                  </a:tcPr>
+                </a:tc>
+              </a:tr>
+              <a:tr h="365760">
+                <a:tc>
+                  <a:txBody>
+                    <a:bodyPr wrap="square"/>
+                    <a:lstStyle/>
+                    <a:p>
+                      <a:r>
+                        <a:rPr sz="950" b="0">
+                          <a:solidFill>
+                            <a:srgbClr val="F0ECE4"/>
+                          </a:solidFill>
+                          <a:latin typeface="Manrope"/>
+                        </a:rPr>
+                        <a:t>Broker signup /brokers</a:t>
+                      </a:r>
+                    </a:p>
+                  </a:txBody>
+                  <a:tcPr marL="109728" marR="73152" marT="27432" marB="27432" anchor="ctr">
+                    <a:solidFill>
+                      <a:srgbClr val="0F141B"/>
+                    </a:solidFill>
+                  </a:tcPr>
+                </a:tc>
+                <a:tc>
+                  <a:txBody>
+                    <a:bodyPr wrap="square"/>
+                    <a:lstStyle/>
+                    <a:p>
+                      <a:r>
+                        <a:rPr sz="950" b="0">
+                          <a:solidFill>
+                            <a:srgbClr val="C2B89A"/>
+                          </a:solidFill>
+                          <a:latin typeface="Manrope"/>
+                        </a:rPr>
+                        <a:t>Agency + RERA BRN early access -&gt; CRM</a:t>
+                      </a:r>
+                    </a:p>
+                  </a:txBody>
+                  <a:tcPr marL="109728" marR="73152" marT="27432" marB="27432" anchor="ctr">
+                    <a:solidFill>
+                      <a:srgbClr val="0F141B"/>
+                    </a:solidFill>
+                  </a:tcPr>
+                </a:tc>
+                <a:tc>
+                  <a:txBody>
+                    <a:bodyPr wrap="square"/>
+                    <a:lstStyle/>
+                    <a:p>
+                      <a:r>
+                        <a:rPr sz="950" b="0">
+                          <a:solidFill>
+                            <a:srgbClr val="C2B89A"/>
+                          </a:solidFill>
+                          <a:latin typeface="Manrope"/>
+                        </a:rPr>
+                        <a:t>LIVE</a:t>
+                      </a:r>
+                    </a:p>
+                  </a:txBody>
+                  <a:tcPr marL="109728" marR="73152" marT="27432" marB="27432" anchor="ctr">
+                    <a:solidFill>
+                      <a:srgbClr val="0F141B"/>
+                    </a:solidFill>
+                  </a:tcPr>
+                </a:tc>
+              </a:tr>
+              <a:tr h="365760">
+                <a:tc>
+                  <a:txBody>
+                    <a:bodyPr wrap="square"/>
+                    <a:lstStyle/>
+                    <a:p>
+                      <a:r>
+                        <a:rPr sz="950" b="0">
+                          <a:solidFill>
+                            <a:srgbClr val="F0ECE4"/>
+                          </a:solidFill>
+                          <a:latin typeface="Manrope"/>
+                        </a:rPr>
+                        <a:t>Engine API /api/engine</a:t>
+                      </a:r>
+                    </a:p>
+                  </a:txBody>
+                  <a:tcPr marL="109728" marR="73152" marT="27432" marB="27432" anchor="ctr">
+                    <a:solidFill>
+                      <a:srgbClr val="121820"/>
+                    </a:solidFill>
+                  </a:tcPr>
+                </a:tc>
+                <a:tc>
+                  <a:txBody>
+                    <a:bodyPr wrap="square"/>
+                    <a:lstStyle/>
+                    <a:p>
+                      <a:r>
+                        <a:rPr sz="950" b="0">
+                          <a:solidFill>
+                            <a:srgbClr val="C2B89A"/>
+                          </a:solidFill>
+                          <a:latin typeface="Manrope"/>
+                        </a:rPr>
+                        <a:t>Programmatic engine + health; foundation for SaaS/licensing</a:t>
+                      </a:r>
+                    </a:p>
+                  </a:txBody>
+                  <a:tcPr marL="109728" marR="73152" marT="27432" marB="27432" anchor="ctr">
+                    <a:solidFill>
+                      <a:srgbClr val="121820"/>
+                    </a:solidFill>
+                  </a:tcPr>
+                </a:tc>
+                <a:tc>
+                  <a:txBody>
+                    <a:bodyPr wrap="square"/>
+                    <a:lstStyle/>
+                    <a:p>
+                      <a:r>
+                        <a:rPr sz="950" b="0">
+                          <a:solidFill>
+                            <a:srgbClr val="C2B89A"/>
+                          </a:solidFill>
+                          <a:latin typeface="Manrope"/>
+                        </a:rPr>
+                        <a:t>LIVE</a:t>
+                      </a:r>
+                    </a:p>
+                  </a:txBody>
+                  <a:tcPr marL="109728" marR="73152" marT="27432" marB="27432" anchor="ctr">
+                    <a:solidFill>
+                      <a:srgbClr val="121820"/>
+                    </a:solidFill>
+                  </a:tcPr>
+                </a:tc>
+              </a:tr>
+            </a:tbl>
+          </a:graphicData>
+        </a:graphic>
+      </p:graphicFrame>
+      <p:sp>
+        <p:nvSpPr>
+          <p:cNvPr id="4" name="Rounded Rectangle 3"/>
+          <p:cNvSpPr/>
+          <p:nvPr/>
+        </p:nvSpPr>
+        <p:spPr>
+          <a:xfrm>
+            <a:off x="640080" y="5623560"/>
+            <a:ext cx="10927080" cy="868680"/>
+          </a:xfrm>
+          <a:prstGeom prst="roundRect">
+            <a:avLst/>
+          </a:prstGeom>
+          <a:solidFill>
+            <a:srgbClr val="1A160C"/>
+          </a:solidFill>
+          <a:ln w="9525">
+            <a:solidFill>
+              <a:srgbClr val="C9A84C"/>
+            </a:solidFill>
+          </a:ln>
+          <a:effectLst/>
+        </p:spPr>
+        <p:style>
+          <a:lnRef idx="1">
+            <a:schemeClr val="accent1"/>
+          </a:lnRef>
+          <a:fillRef idx="3">
+            <a:schemeClr val="accent1"/>
+          </a:fillRef>
+          <a:effectRef idx="2">
+            <a:schemeClr val="accent1"/>
+          </a:effectRef>
+          <a:fontRef idx="minor">
+            <a:schemeClr val="lt1"/>
+          </a:fontRef>
+        </p:style>
+        <p:txBody>
+          <a:bodyPr rtlCol="0" anchor="ctr"/>
+          <a:lstStyle/>
+          <a:p>
+            <a:pPr algn="ctr"/>
+          </a:p>
+        </p:txBody>
+      </p:sp>
+      <p:sp>
+        <p:nvSpPr>
+          <p:cNvPr id="5" name="TextBox 4"/>
+          <p:cNvSpPr txBox="1"/>
+          <p:nvPr/>
+        </p:nvSpPr>
+        <p:spPr>
+          <a:xfrm>
+            <a:off x="868680" y="5733288"/>
+            <a:ext cx="10469880" cy="685800"/>
+          </a:xfrm>
+          <a:prstGeom prst="rect">
+            <a:avLst/>
+          </a:prstGeom>
+          <a:noFill/>
+        </p:spPr>
+        <p:txBody>
+          <a:bodyPr wrap="square" anchor="ctr">
+            <a:spAutoFit/>
+          </a:bodyPr>
+          <a:lstStyle/>
+          <a:p>
+            <a:pPr algn="l">
+              <a:lnSpc>
+                <a:spcPct val="110000"/>
+              </a:lnSpc>
+              <a:spcAft>
+                <a:spcPts val="600"/>
+              </a:spcAft>
+            </a:pPr>
+            <a:r>
+              <a:rPr sz="1050" b="0" i="0">
+                <a:solidFill>
+                  <a:srgbClr val="C2B89A"/>
+                </a:solidFill>
+                <a:latin typeface="Manrope"/>
+              </a:rPr>
+              <a:t>Planned (Phase 2-3 - explicitly NOT built yet): SaaS subscriptions &amp; billing (AED 199-2,500/mo) · pay-per-report credits · buyer-requirements auto-matching · white-label / enterprise data API · full 7.71 GB DLD cache in production (builder ready).</a:t>
+            </a:r>
+          </a:p>
+        </p:txBody>
+      </p:sp>
+    </p:spTree>
+  </p:cSld>
+  <p:clrMapOvr>
+    <a:masterClrMapping/>
+  </p:clrMapOvr>
+</p:sld>
+</file>
+
+<file path=ppt/slides/slide7.xml><?xml version="1.0" encoding="utf-8"?>
 <p:sld xmlns:a="http://schemas.openxmlformats.org/drawingml/2006/main" xmlns:p="http://schemas.openxmlformats.org/presentationml/2006/main" xmlns:r="http://schemas.openxmlformats.org/officeDocument/2006/relationships">
   <p:cSld>
     <p:bg>
@@ -13001,7 +14835,7 @@
 </p:sld>
 </file>
 
-<file path=ppt/slides/slide7.xml><?xml version="1.0" encoding="utf-8"?>
+<file path=ppt/slides/slide8.xml><?xml version="1.0" encoding="utf-8"?>
 <p:sld xmlns:a="http://schemas.openxmlformats.org/drawingml/2006/main" xmlns:p="http://schemas.openxmlformats.org/presentationml/2006/main" xmlns:r="http://schemas.openxmlformats.org/officeDocument/2006/relationships">
   <p:cSld>
     <p:bg>
@@ -14099,7 +15933,7 @@
 </p:sld>
 </file>
 
-<file path=ppt/slides/slide8.xml><?xml version="1.0" encoding="utf-8"?>
+<file path=ppt/slides/slide9.xml><?xml version="1.0" encoding="utf-8"?>
 <p:sld xmlns:a="http://schemas.openxmlformats.org/drawingml/2006/main" xmlns:p="http://schemas.openxmlformats.org/presentationml/2006/main" xmlns:r="http://schemas.openxmlformats.org/officeDocument/2006/relationships">
   <p:cSld>
     <p:bg>
@@ -14796,887 +16630,6 @@
                 <a:latin typeface="Manrope"/>
               </a:rPr>
               <a:t>Break-even ≈ 1.5 mandates/month — reachable with the founder closing alone.</a:t>
-            </a:r>
-          </a:p>
-        </p:txBody>
-      </p:sp>
-    </p:spTree>
-  </p:cSld>
-  <p:clrMapOvr>
-    <a:masterClrMapping/>
-  </p:clrMapOvr>
-</p:sld>
-</file>
-
-<file path=ppt/slides/slide9.xml><?xml version="1.0" encoding="utf-8"?>
-<p:sld xmlns:a="http://schemas.openxmlformats.org/drawingml/2006/main" xmlns:p="http://schemas.openxmlformats.org/presentationml/2006/main" xmlns:r="http://schemas.openxmlformats.org/officeDocument/2006/relationships">
-  <p:cSld>
-    <p:bg>
-      <p:bgPr>
-        <a:solidFill>
-          <a:srgbClr val="0C1118"/>
-        </a:solidFill>
-        <a:effectLst/>
-      </p:bgPr>
-    </p:bg>
-    <p:spTree>
-      <p:nvGrpSpPr>
-        <p:cNvPr id="1" name=""/>
-        <p:cNvGrpSpPr/>
-        <p:nvPr/>
-      </p:nvGrpSpPr>
-      <p:grpSpPr/>
-      <p:sp>
-        <p:nvSpPr>
-          <p:cNvPr id="2" name="TextBox 1"/>
-          <p:cNvSpPr txBox="1"/>
-          <p:nvPr/>
-        </p:nvSpPr>
-        <p:spPr>
-          <a:xfrm>
-            <a:off x="640080" y="502920"/>
-            <a:ext cx="10972800" cy="1554480"/>
-          </a:xfrm>
-          <a:prstGeom prst="rect">
-            <a:avLst/>
-          </a:prstGeom>
-          <a:noFill/>
-        </p:spPr>
-        <p:txBody>
-          <a:bodyPr wrap="square" anchor="t">
-            <a:spAutoFit/>
-          </a:bodyPr>
-          <a:lstStyle/>
-          <a:p>
-            <a:pPr algn="l">
-              <a:lnSpc>
-                <a:spcPct val="105000"/>
-              </a:lnSpc>
-              <a:spcAft>
-                <a:spcPts val="600"/>
-              </a:spcAft>
-            </a:pPr>
-            <a:r>
-              <a:rPr sz="1200" b="1" i="0">
-                <a:solidFill>
-                  <a:srgbClr val="C9A84C"/>
-                </a:solidFill>
-                <a:latin typeface="Manrope"/>
-              </a:rPr>
-              <a:t>FINANCIAL MODEL · 3 YEARS</a:t>
-            </a:r>
-          </a:p>
-          <a:p>
-            <a:pPr algn="l">
-              <a:lnSpc>
-                <a:spcPct val="100000"/>
-              </a:lnSpc>
-              <a:spcAft>
-                <a:spcPts val="200"/>
-              </a:spcAft>
-            </a:pPr>
-            <a:r>
-              <a:rPr sz="3400" b="1" i="0">
-                <a:solidFill>
-                  <a:srgbClr val="E8D5A3"/>
-                </a:solidFill>
-                <a:latin typeface="Cormorant Garamond"/>
-              </a:rPr>
-              <a:t>Capital-Light. Cash-Positive Fast.</a:t>
-            </a:r>
-          </a:p>
-        </p:txBody>
-      </p:sp>
-      <p:sp>
-        <p:nvSpPr>
-          <p:cNvPr id="3" name="Rounded Rectangle 2"/>
-          <p:cNvSpPr/>
-          <p:nvPr/>
-        </p:nvSpPr>
-        <p:spPr>
-          <a:xfrm>
-            <a:off x="640080" y="2103120"/>
-            <a:ext cx="3474720" cy="1554480"/>
-          </a:xfrm>
-          <a:prstGeom prst="roundRect">
-            <a:avLst/>
-          </a:prstGeom>
-          <a:solidFill>
-            <a:srgbClr val="161F2B"/>
-          </a:solidFill>
-          <a:ln w="9525">
-            <a:solidFill>
-              <a:srgbClr val="C9A84C"/>
-            </a:solidFill>
-          </a:ln>
-          <a:effectLst/>
-        </p:spPr>
-        <p:style>
-          <a:lnRef idx="1">
-            <a:schemeClr val="accent1"/>
-          </a:lnRef>
-          <a:fillRef idx="3">
-            <a:schemeClr val="accent1"/>
-          </a:fillRef>
-          <a:effectRef idx="2">
-            <a:schemeClr val="accent1"/>
-          </a:effectRef>
-          <a:fontRef idx="minor">
-            <a:schemeClr val="lt1"/>
-          </a:fontRef>
-        </p:style>
-        <p:txBody>
-          <a:bodyPr rtlCol="0" anchor="ctr"/>
-          <a:lstStyle/>
-          <a:p>
-            <a:pPr algn="ctr"/>
-          </a:p>
-        </p:txBody>
-      </p:sp>
-      <p:sp>
-        <p:nvSpPr>
-          <p:cNvPr id="4" name="TextBox 3"/>
-          <p:cNvSpPr txBox="1"/>
-          <p:nvPr/>
-        </p:nvSpPr>
-        <p:spPr>
-          <a:xfrm>
-            <a:off x="640080" y="2286000"/>
-            <a:ext cx="3474720" cy="1188719"/>
-          </a:xfrm>
-          <a:prstGeom prst="rect">
-            <a:avLst/>
-          </a:prstGeom>
-          <a:noFill/>
-        </p:spPr>
-        <p:txBody>
-          <a:bodyPr wrap="square" anchor="ctr">
-            <a:spAutoFit/>
-          </a:bodyPr>
-          <a:lstStyle/>
-          <a:p>
-            <a:pPr algn="ctr">
-              <a:lnSpc>
-                <a:spcPct val="105000"/>
-              </a:lnSpc>
-              <a:spcAft>
-                <a:spcPts val="400"/>
-              </a:spcAft>
-            </a:pPr>
-            <a:r>
-              <a:rPr sz="3000" b="1" i="0">
-                <a:solidFill>
-                  <a:srgbClr val="C9A84C"/>
-                </a:solidFill>
-                <a:latin typeface="Cormorant Garamond"/>
-              </a:rPr>
-              <a:t>AED 3.56M</a:t>
-            </a:r>
-          </a:p>
-          <a:p>
-            <a:pPr algn="ctr">
-              <a:lnSpc>
-                <a:spcPct val="105000"/>
-              </a:lnSpc>
-              <a:spcAft>
-                <a:spcPts val="200"/>
-              </a:spcAft>
-            </a:pPr>
-            <a:r>
-              <a:rPr sz="1050" b="1" i="0">
-                <a:solidFill>
-                  <a:srgbClr val="7A6F5E"/>
-                </a:solidFill>
-                <a:latin typeface="Manrope"/>
-              </a:rPr>
-              <a:t>YEAR 1 REVENUE</a:t>
-            </a:r>
-          </a:p>
-          <a:p>
-            <a:pPr algn="ctr">
-              <a:lnSpc>
-                <a:spcPct val="105000"/>
-              </a:lnSpc>
-              <a:spcAft>
-                <a:spcPts val="0"/>
-              </a:spcAft>
-            </a:pPr>
-            <a:r>
-              <a:rPr sz="1000" b="0" i="0">
-                <a:solidFill>
-                  <a:srgbClr val="C2B89A"/>
-                </a:solidFill>
-                <a:latin typeface="Manrope"/>
-              </a:rPr>
-              <a:t>EBITDA 1.75M · 49%</a:t>
-            </a:r>
-          </a:p>
-        </p:txBody>
-      </p:sp>
-      <p:sp>
-        <p:nvSpPr>
-          <p:cNvPr id="5" name="Rounded Rectangle 4"/>
-          <p:cNvSpPr/>
-          <p:nvPr/>
-        </p:nvSpPr>
-        <p:spPr>
-          <a:xfrm>
-            <a:off x="4389120" y="2103120"/>
-            <a:ext cx="3474720" cy="1554480"/>
-          </a:xfrm>
-          <a:prstGeom prst="roundRect">
-            <a:avLst/>
-          </a:prstGeom>
-          <a:solidFill>
-            <a:srgbClr val="161F2B"/>
-          </a:solidFill>
-          <a:ln w="9525">
-            <a:solidFill>
-              <a:srgbClr val="C9A84C"/>
-            </a:solidFill>
-          </a:ln>
-          <a:effectLst/>
-        </p:spPr>
-        <p:style>
-          <a:lnRef idx="1">
-            <a:schemeClr val="accent1"/>
-          </a:lnRef>
-          <a:fillRef idx="3">
-            <a:schemeClr val="accent1"/>
-          </a:fillRef>
-          <a:effectRef idx="2">
-            <a:schemeClr val="accent1"/>
-          </a:effectRef>
-          <a:fontRef idx="minor">
-            <a:schemeClr val="lt1"/>
-          </a:fontRef>
-        </p:style>
-        <p:txBody>
-          <a:bodyPr rtlCol="0" anchor="ctr"/>
-          <a:lstStyle/>
-          <a:p>
-            <a:pPr algn="ctr"/>
-          </a:p>
-        </p:txBody>
-      </p:sp>
-      <p:sp>
-        <p:nvSpPr>
-          <p:cNvPr id="6" name="TextBox 5"/>
-          <p:cNvSpPr txBox="1"/>
-          <p:nvPr/>
-        </p:nvSpPr>
-        <p:spPr>
-          <a:xfrm>
-            <a:off x="4389120" y="2286000"/>
-            <a:ext cx="3474720" cy="1188719"/>
-          </a:xfrm>
-          <a:prstGeom prst="rect">
-            <a:avLst/>
-          </a:prstGeom>
-          <a:noFill/>
-        </p:spPr>
-        <p:txBody>
-          <a:bodyPr wrap="square" anchor="ctr">
-            <a:spAutoFit/>
-          </a:bodyPr>
-          <a:lstStyle/>
-          <a:p>
-            <a:pPr algn="ctr">
-              <a:lnSpc>
-                <a:spcPct val="105000"/>
-              </a:lnSpc>
-              <a:spcAft>
-                <a:spcPts val="400"/>
-              </a:spcAft>
-            </a:pPr>
-            <a:r>
-              <a:rPr sz="3000" b="1" i="0">
-                <a:solidFill>
-                  <a:srgbClr val="C9A84C"/>
-                </a:solidFill>
-                <a:latin typeface="Cormorant Garamond"/>
-              </a:rPr>
-              <a:t>AED 10.07M</a:t>
-            </a:r>
-          </a:p>
-          <a:p>
-            <a:pPr algn="ctr">
-              <a:lnSpc>
-                <a:spcPct val="105000"/>
-              </a:lnSpc>
-              <a:spcAft>
-                <a:spcPts val="200"/>
-              </a:spcAft>
-            </a:pPr>
-            <a:r>
-              <a:rPr sz="1050" b="1" i="0">
-                <a:solidFill>
-                  <a:srgbClr val="7A6F5E"/>
-                </a:solidFill>
-                <a:latin typeface="Manrope"/>
-              </a:rPr>
-              <a:t>YEAR 2 REVENUE</a:t>
-            </a:r>
-          </a:p>
-          <a:p>
-            <a:pPr algn="ctr">
-              <a:lnSpc>
-                <a:spcPct val="105000"/>
-              </a:lnSpc>
-              <a:spcAft>
-                <a:spcPts val="0"/>
-              </a:spcAft>
-            </a:pPr>
-            <a:r>
-              <a:rPr sz="1000" b="0" i="0">
-                <a:solidFill>
-                  <a:srgbClr val="C2B89A"/>
-                </a:solidFill>
-                <a:latin typeface="Manrope"/>
-              </a:rPr>
-              <a:t>EBITDA 6.53M · 65%</a:t>
-            </a:r>
-          </a:p>
-        </p:txBody>
-      </p:sp>
-      <p:sp>
-        <p:nvSpPr>
-          <p:cNvPr id="7" name="Rounded Rectangle 6"/>
-          <p:cNvSpPr/>
-          <p:nvPr/>
-        </p:nvSpPr>
-        <p:spPr>
-          <a:xfrm>
-            <a:off x="8138160" y="2103120"/>
-            <a:ext cx="3474720" cy="1554480"/>
-          </a:xfrm>
-          <a:prstGeom prst="roundRect">
-            <a:avLst/>
-          </a:prstGeom>
-          <a:solidFill>
-            <a:srgbClr val="161F2B"/>
-          </a:solidFill>
-          <a:ln w="9525">
-            <a:solidFill>
-              <a:srgbClr val="C9A84C"/>
-            </a:solidFill>
-          </a:ln>
-          <a:effectLst/>
-        </p:spPr>
-        <p:style>
-          <a:lnRef idx="1">
-            <a:schemeClr val="accent1"/>
-          </a:lnRef>
-          <a:fillRef idx="3">
-            <a:schemeClr val="accent1"/>
-          </a:fillRef>
-          <a:effectRef idx="2">
-            <a:schemeClr val="accent1"/>
-          </a:effectRef>
-          <a:fontRef idx="minor">
-            <a:schemeClr val="lt1"/>
-          </a:fontRef>
-        </p:style>
-        <p:txBody>
-          <a:bodyPr rtlCol="0" anchor="ctr"/>
-          <a:lstStyle/>
-          <a:p>
-            <a:pPr algn="ctr"/>
-          </a:p>
-        </p:txBody>
-      </p:sp>
-      <p:sp>
-        <p:nvSpPr>
-          <p:cNvPr id="8" name="TextBox 7"/>
-          <p:cNvSpPr txBox="1"/>
-          <p:nvPr/>
-        </p:nvSpPr>
-        <p:spPr>
-          <a:xfrm>
-            <a:off x="8138160" y="2286000"/>
-            <a:ext cx="3474720" cy="1188719"/>
-          </a:xfrm>
-          <a:prstGeom prst="rect">
-            <a:avLst/>
-          </a:prstGeom>
-          <a:noFill/>
-        </p:spPr>
-        <p:txBody>
-          <a:bodyPr wrap="square" anchor="ctr">
-            <a:spAutoFit/>
-          </a:bodyPr>
-          <a:lstStyle/>
-          <a:p>
-            <a:pPr algn="ctr">
-              <a:lnSpc>
-                <a:spcPct val="105000"/>
-              </a:lnSpc>
-              <a:spcAft>
-                <a:spcPts val="400"/>
-              </a:spcAft>
-            </a:pPr>
-            <a:r>
-              <a:rPr sz="3000" b="1" i="0">
-                <a:solidFill>
-                  <a:srgbClr val="C9A84C"/>
-                </a:solidFill>
-                <a:latin typeface="Cormorant Garamond"/>
-              </a:rPr>
-              <a:t>AED 19.98M</a:t>
-            </a:r>
-          </a:p>
-          <a:p>
-            <a:pPr algn="ctr">
-              <a:lnSpc>
-                <a:spcPct val="105000"/>
-              </a:lnSpc>
-              <a:spcAft>
-                <a:spcPts val="200"/>
-              </a:spcAft>
-            </a:pPr>
-            <a:r>
-              <a:rPr sz="1050" b="1" i="0">
-                <a:solidFill>
-                  <a:srgbClr val="7A6F5E"/>
-                </a:solidFill>
-                <a:latin typeface="Manrope"/>
-              </a:rPr>
-              <a:t>YEAR 3 REVENUE</a:t>
-            </a:r>
-          </a:p>
-          <a:p>
-            <a:pPr algn="ctr">
-              <a:lnSpc>
-                <a:spcPct val="105000"/>
-              </a:lnSpc>
-              <a:spcAft>
-                <a:spcPts val="0"/>
-              </a:spcAft>
-            </a:pPr>
-            <a:r>
-              <a:rPr sz="1000" b="0" i="0">
-                <a:solidFill>
-                  <a:srgbClr val="C2B89A"/>
-                </a:solidFill>
-                <a:latin typeface="Manrope"/>
-              </a:rPr>
-              <a:t>EBITDA 15.12M · 76%</a:t>
-            </a:r>
-          </a:p>
-        </p:txBody>
-      </p:sp>
-      <p:sp>
-        <p:nvSpPr>
-          <p:cNvPr id="9" name="Rounded Rectangle 8"/>
-          <p:cNvSpPr/>
-          <p:nvPr/>
-        </p:nvSpPr>
-        <p:spPr>
-          <a:xfrm>
-            <a:off x="640080" y="4023360"/>
-            <a:ext cx="3566160" cy="2011680"/>
-          </a:xfrm>
-          <a:prstGeom prst="roundRect">
-            <a:avLst/>
-          </a:prstGeom>
-          <a:solidFill>
-            <a:srgbClr val="161F2B"/>
-          </a:solidFill>
-          <a:ln w="9525">
-            <a:solidFill>
-              <a:srgbClr val="C9A84C"/>
-            </a:solidFill>
-          </a:ln>
-          <a:effectLst/>
-        </p:spPr>
-        <p:style>
-          <a:lnRef idx="1">
-            <a:schemeClr val="accent1"/>
-          </a:lnRef>
-          <a:fillRef idx="3">
-            <a:schemeClr val="accent1"/>
-          </a:fillRef>
-          <a:effectRef idx="2">
-            <a:schemeClr val="accent1"/>
-          </a:effectRef>
-          <a:fontRef idx="minor">
-            <a:schemeClr val="lt1"/>
-          </a:fontRef>
-        </p:style>
-        <p:txBody>
-          <a:bodyPr rtlCol="0" anchor="ctr"/>
-          <a:lstStyle/>
-          <a:p>
-            <a:pPr algn="ctr"/>
-          </a:p>
-        </p:txBody>
-      </p:sp>
-      <p:sp>
-        <p:nvSpPr>
-          <p:cNvPr id="10" name="TextBox 9"/>
-          <p:cNvSpPr txBox="1"/>
-          <p:nvPr/>
-        </p:nvSpPr>
-        <p:spPr>
-          <a:xfrm>
-            <a:off x="868680" y="4187952"/>
-            <a:ext cx="3108960" cy="1682496"/>
-          </a:xfrm>
-          <a:prstGeom prst="rect">
-            <a:avLst/>
-          </a:prstGeom>
-          <a:noFill/>
-        </p:spPr>
-        <p:txBody>
-          <a:bodyPr wrap="square" anchor="t">
-            <a:spAutoFit/>
-          </a:bodyPr>
-          <a:lstStyle/>
-          <a:p>
-            <a:pPr algn="l">
-              <a:lnSpc>
-                <a:spcPct val="105000"/>
-              </a:lnSpc>
-              <a:spcAft>
-                <a:spcPts val="600"/>
-              </a:spcAft>
-            </a:pPr>
-            <a:r>
-              <a:rPr sz="1400" b="1" i="0">
-                <a:solidFill>
-                  <a:srgbClr val="E8D5A3"/>
-                </a:solidFill>
-                <a:latin typeface="Manrope"/>
-              </a:rPr>
-              <a:t>Two arms</a:t>
-            </a:r>
-          </a:p>
-          <a:p>
-            <a:pPr algn="l">
-              <a:lnSpc>
-                <a:spcPct val="105000"/>
-              </a:lnSpc>
-              <a:spcAft>
-                <a:spcPts val="400"/>
-              </a:spcAft>
-            </a:pPr>
-            <a:r>
-              <a:rPr sz="1150" b="0" i="0">
-                <a:solidFill>
-                  <a:srgbClr val="C2B89A"/>
-                </a:solidFill>
-                <a:latin typeface="Manrope"/>
-              </a:rPr>
-              <a:t>Brokerage = GCI (~98% gross).</a:t>
-            </a:r>
-          </a:p>
-          <a:p>
-            <a:pPr algn="l">
-              <a:lnSpc>
-                <a:spcPct val="105000"/>
-              </a:lnSpc>
-              <a:spcAft>
-                <a:spcPts val="400"/>
-              </a:spcAft>
-            </a:pPr>
-            <a:r>
-              <a:rPr sz="1150" b="0" i="0">
-                <a:solidFill>
-                  <a:srgbClr val="C2B89A"/>
-                </a:solidFill>
-                <a:latin typeface="Manrope"/>
-              </a:rPr>
-              <a:t>SaaS COGS only AED 120K -&gt; 264K.</a:t>
-            </a:r>
-          </a:p>
-        </p:txBody>
-      </p:sp>
-      <p:sp>
-        <p:nvSpPr>
-          <p:cNvPr id="11" name="Rounded Rectangle 10"/>
-          <p:cNvSpPr/>
-          <p:nvPr/>
-        </p:nvSpPr>
-        <p:spPr>
-          <a:xfrm>
-            <a:off x="4343400" y="4023360"/>
-            <a:ext cx="3566160" cy="2011680"/>
-          </a:xfrm>
-          <a:prstGeom prst="roundRect">
-            <a:avLst/>
-          </a:prstGeom>
-          <a:solidFill>
-            <a:srgbClr val="161F2B"/>
-          </a:solidFill>
-          <a:ln w="9525">
-            <a:solidFill>
-              <a:srgbClr val="C9A84C"/>
-            </a:solidFill>
-          </a:ln>
-          <a:effectLst/>
-        </p:spPr>
-        <p:style>
-          <a:lnRef idx="1">
-            <a:schemeClr val="accent1"/>
-          </a:lnRef>
-          <a:fillRef idx="3">
-            <a:schemeClr val="accent1"/>
-          </a:fillRef>
-          <a:effectRef idx="2">
-            <a:schemeClr val="accent1"/>
-          </a:effectRef>
-          <a:fontRef idx="minor">
-            <a:schemeClr val="lt1"/>
-          </a:fontRef>
-        </p:style>
-        <p:txBody>
-          <a:bodyPr rtlCol="0" anchor="ctr"/>
-          <a:lstStyle/>
-          <a:p>
-            <a:pPr algn="ctr"/>
-          </a:p>
-        </p:txBody>
-      </p:sp>
-      <p:sp>
-        <p:nvSpPr>
-          <p:cNvPr id="12" name="TextBox 11"/>
-          <p:cNvSpPr txBox="1"/>
-          <p:nvPr/>
-        </p:nvSpPr>
-        <p:spPr>
-          <a:xfrm>
-            <a:off x="4572000" y="4187952"/>
-            <a:ext cx="3108960" cy="1682496"/>
-          </a:xfrm>
-          <a:prstGeom prst="rect">
-            <a:avLst/>
-          </a:prstGeom>
-          <a:noFill/>
-        </p:spPr>
-        <p:txBody>
-          <a:bodyPr wrap="square" anchor="t">
-            <a:spAutoFit/>
-          </a:bodyPr>
-          <a:lstStyle/>
-          <a:p>
-            <a:pPr algn="l">
-              <a:lnSpc>
-                <a:spcPct val="105000"/>
-              </a:lnSpc>
-              <a:spcAft>
-                <a:spcPts val="600"/>
-              </a:spcAft>
-            </a:pPr>
-            <a:r>
-              <a:rPr sz="1400" b="1" i="0">
-                <a:solidFill>
-                  <a:srgbClr val="E8D5A3"/>
-                </a:solidFill>
-                <a:latin typeface="Manrope"/>
-              </a:rPr>
-              <a:t>Breakeven</a:t>
-            </a:r>
-          </a:p>
-          <a:p>
-            <a:pPr algn="l">
-              <a:lnSpc>
-                <a:spcPct val="105000"/>
-              </a:lnSpc>
-              <a:spcAft>
-                <a:spcPts val="400"/>
-              </a:spcAft>
-            </a:pPr>
-            <a:r>
-              <a:rPr sz="1150" b="0" i="0">
-                <a:solidFill>
-                  <a:srgbClr val="C2B89A"/>
-                </a:solidFill>
-                <a:latin typeface="Manrope"/>
-              </a:rPr>
-              <a:t>Brokerage ~M7 (GCI carries Y1).</a:t>
-            </a:r>
-          </a:p>
-          <a:p>
-            <a:pPr algn="l">
-              <a:lnSpc>
-                <a:spcPct val="105000"/>
-              </a:lnSpc>
-              <a:spcAft>
-                <a:spcPts val="400"/>
-              </a:spcAft>
-            </a:pPr>
-            <a:r>
-              <a:rPr sz="1150" b="0" i="0">
-                <a:solidFill>
-                  <a:srgbClr val="C2B89A"/>
-                </a:solidFill>
-                <a:latin typeface="Manrope"/>
-              </a:rPr>
-              <a:t>SaaS self-sustaining ~M18.</a:t>
-            </a:r>
-          </a:p>
-          <a:p>
-            <a:pPr algn="l">
-              <a:lnSpc>
-                <a:spcPct val="105000"/>
-              </a:lnSpc>
-              <a:spcAft>
-                <a:spcPts val="400"/>
-              </a:spcAft>
-            </a:pPr>
-            <a:r>
-              <a:rPr sz="1150" b="0" i="0">
-                <a:solidFill>
-                  <a:srgbClr val="C2B89A"/>
-                </a:solidFill>
-                <a:latin typeface="Manrope"/>
-              </a:rPr>
-              <a:t>Positive EBITDA from Year 2.</a:t>
-            </a:r>
-          </a:p>
-        </p:txBody>
-      </p:sp>
-      <p:sp>
-        <p:nvSpPr>
-          <p:cNvPr id="13" name="Rounded Rectangle 12"/>
-          <p:cNvSpPr/>
-          <p:nvPr/>
-        </p:nvSpPr>
-        <p:spPr>
-          <a:xfrm>
-            <a:off x="8046720" y="4023360"/>
-            <a:ext cx="3520440" cy="2011680"/>
-          </a:xfrm>
-          <a:prstGeom prst="roundRect">
-            <a:avLst/>
-          </a:prstGeom>
-          <a:solidFill>
-            <a:srgbClr val="161F2B"/>
-          </a:solidFill>
-          <a:ln w="9525">
-            <a:solidFill>
-              <a:srgbClr val="C9A84C"/>
-            </a:solidFill>
-          </a:ln>
-          <a:effectLst/>
-        </p:spPr>
-        <p:style>
-          <a:lnRef idx="1">
-            <a:schemeClr val="accent1"/>
-          </a:lnRef>
-          <a:fillRef idx="3">
-            <a:schemeClr val="accent1"/>
-          </a:fillRef>
-          <a:effectRef idx="2">
-            <a:schemeClr val="accent1"/>
-          </a:effectRef>
-          <a:fontRef idx="minor">
-            <a:schemeClr val="lt1"/>
-          </a:fontRef>
-        </p:style>
-        <p:txBody>
-          <a:bodyPr rtlCol="0" anchor="ctr"/>
-          <a:lstStyle/>
-          <a:p>
-            <a:pPr algn="ctr"/>
-          </a:p>
-        </p:txBody>
-      </p:sp>
-      <p:sp>
-        <p:nvSpPr>
-          <p:cNvPr id="14" name="TextBox 13"/>
-          <p:cNvSpPr txBox="1"/>
-          <p:nvPr/>
-        </p:nvSpPr>
-        <p:spPr>
-          <a:xfrm>
-            <a:off x="8275320" y="4187952"/>
-            <a:ext cx="3063240" cy="1682496"/>
-          </a:xfrm>
-          <a:prstGeom prst="rect">
-            <a:avLst/>
-          </a:prstGeom>
-          <a:noFill/>
-        </p:spPr>
-        <p:txBody>
-          <a:bodyPr wrap="square" anchor="t">
-            <a:spAutoFit/>
-          </a:bodyPr>
-          <a:lstStyle/>
-          <a:p>
-            <a:pPr algn="l">
-              <a:lnSpc>
-                <a:spcPct val="105000"/>
-              </a:lnSpc>
-              <a:spcAft>
-                <a:spcPts val="600"/>
-              </a:spcAft>
-            </a:pPr>
-            <a:r>
-              <a:rPr sz="1400" b="1" i="0">
-                <a:solidFill>
-                  <a:srgbClr val="E8D5A3"/>
-                </a:solidFill>
-                <a:latin typeface="Manrope"/>
-              </a:rPr>
-              <a:t>Indicative Y3 value</a:t>
-            </a:r>
-          </a:p>
-          <a:p>
-            <a:pPr algn="l">
-              <a:lnSpc>
-                <a:spcPct val="105000"/>
-              </a:lnSpc>
-              <a:spcAft>
-                <a:spcPts val="400"/>
-              </a:spcAft>
-            </a:pPr>
-            <a:r>
-              <a:rPr sz="1150" b="0" i="0">
-                <a:solidFill>
-                  <a:srgbClr val="C2B89A"/>
-                </a:solidFill>
-                <a:latin typeface="Manrope"/>
-              </a:rPr>
-              <a:t>SaaS ~1.85M ARR x ~10x</a:t>
-            </a:r>
-          </a:p>
-          <a:p>
-            <a:pPr algn="l">
-              <a:lnSpc>
-                <a:spcPct val="105000"/>
-              </a:lnSpc>
-              <a:spcAft>
-                <a:spcPts val="400"/>
-              </a:spcAft>
-            </a:pPr>
-            <a:r>
-              <a:rPr sz="1150" b="0" i="0">
-                <a:solidFill>
-                  <a:srgbClr val="C2B89A"/>
-                </a:solidFill>
-                <a:latin typeface="Manrope"/>
-              </a:rPr>
-              <a:t>+ brokerage EBITDA x ~4x</a:t>
-            </a:r>
-          </a:p>
-          <a:p>
-            <a:pPr algn="l">
-              <a:lnSpc>
-                <a:spcPct val="105000"/>
-              </a:lnSpc>
-              <a:spcAft>
-                <a:spcPts val="400"/>
-              </a:spcAft>
-            </a:pPr>
-            <a:r>
-              <a:rPr sz="1150" b="0" i="0">
-                <a:solidFill>
-                  <a:srgbClr val="C2B89A"/>
-                </a:solidFill>
-                <a:latin typeface="Manrope"/>
-              </a:rPr>
-              <a:t>-&gt; ~AED 40-60M · dual exit</a:t>
             </a:r>
           </a:p>
         </p:txBody>

</xml_diff>